<commit_message>
docs(hardware): add rotary encoder options slide (5a EC11 / 5b AS5600 magnetic / 5c ANO nav)
</commit_message>
<xml_diff>
--- a/docs/hardware/bom_deck/PlatypusOne_BOM_Components.pptx
+++ b/docs/hardware/bom_deck/PlatypusOne_BOM_Components.pptx
@@ -14,9 +14,10 @@
     <p:sldId id="262" r:id="rId8"/>
     <p:sldId id="263" r:id="rId9"/>
     <p:sldId id="264" r:id="rId10"/>
+    <p:sldId id="265" r:id="rId11"/>
   </p:sldIdLst>
   <p:notesMasterIdLst>
-    <p:notesMasterId r:id="rId11"/>
+    <p:notesMasterId r:id="rId12"/>
   </p:notesMasterIdLst>
   <p:sldSz cx="12192000" cy="6858000"/>
   <p:notesSz cx="6858000" cy="12192000"/>
@@ -534,6 +535,94 @@
             <a:fld id="{F7021451-1387-4CA6-816F-3879F97B5CBC}" type="slidenum">
               <a:rPr lang="en-US"/>
               <a:t>1</a:t>
+            </a:fld>
+            <a:endParaRPr lang="en-US"/>
+          </a:p>
+        </p:txBody>
+      </p:sp>
+    </p:spTree>
+    <p:extLst>
+      <p:ext uri="{BB962C8B-B14F-4D97-AF65-F5344CB8AC3E}">
+        <p14:creationId xmlns:p14="http://schemas.microsoft.com/office/powerpoint/2010/main" val="1024086991"/>
+      </p:ext>
+    </p:extLst>
+  </p:cSld>
+  <p:clrMapOvr>
+    <a:masterClrMapping/>
+  </p:clrMapOvr>
+</p:notes>
+</file>
+
+<file path=ppt/notesSlides/notesSlide10.xml><?xml version="1.0" encoding="utf-8"?>
+<p:notes xmlns:a="http://schemas.openxmlformats.org/drawingml/2006/main" xmlns:r="http://schemas.openxmlformats.org/officeDocument/2006/relationships" xmlns:p="http://schemas.openxmlformats.org/presentationml/2006/main">
+  <p:cSld>
+    <p:spTree>
+      <p:nvGrpSpPr>
+        <p:cNvPr id="1" name=""/>
+        <p:cNvGrpSpPr/>
+        <p:nvPr/>
+      </p:nvGrpSpPr>
+      <p:grpSpPr>
+        <a:xfrm>
+          <a:off x="0" y="0"/>
+          <a:ext cx="0" cy="0"/>
+          <a:chOff x="0" y="0"/>
+          <a:chExt cx="0" cy="0"/>
+        </a:xfrm>
+      </p:grpSpPr>
+      <p:sp>
+        <p:nvSpPr>
+          <p:cNvPr id="2" name="Slide Image Placeholder 1"/>
+          <p:cNvSpPr>
+            <a:spLocks noGrp="1" noRot="1" noChangeAspect="1"/>
+          </p:cNvSpPr>
+          <p:nvPr>
+            <p:ph type="sldImg"/>
+          </p:nvPr>
+        </p:nvSpPr>
+        <p:spPr/>
+      </p:sp>
+      <p:sp>
+        <p:nvSpPr>
+          <p:cNvPr id="3" name="Notes Placeholder 2"/>
+          <p:cNvSpPr>
+            <a:spLocks noGrp="1"/>
+          </p:cNvSpPr>
+          <p:nvPr>
+            <p:ph type="body" idx="1"/>
+          </p:nvPr>
+        </p:nvSpPr>
+        <p:spPr/>
+        <p:txBody>
+          <a:bodyPr/>
+          <a:lstStyle/>
+          <a:p>
+            <a:r>
+              <a:rPr lang="en-US" dirty="0"/>
+              <a:t/>
+            </a:r>
+            <a:endParaRPr lang="en-US" dirty="0"/>
+          </a:p>
+        </p:txBody>
+      </p:sp>
+      <p:sp>
+        <p:nvSpPr>
+          <p:cNvPr id="4" name="Slide Number Placeholder 3"/>
+          <p:cNvSpPr>
+            <a:spLocks noGrp="1"/>
+          </p:cNvSpPr>
+          <p:nvPr>
+            <p:ph type="sldNum" sz="quarter" idx="10"/>
+          </p:nvPr>
+        </p:nvSpPr>
+        <p:spPr/>
+        <p:txBody>
+          <a:bodyPr/>
+          <a:lstStyle/>
+          <a:p>
+            <a:fld id="{F7021451-1387-4CA6-816F-3879F97B5CBC}" type="slidenum">
+              <a:rPr lang="en-US"/>
+              <a:t>10</a:t>
             </a:fld>
             <a:endParaRPr lang="en-US"/>
           </a:p>
@@ -1775,6 +1864,572 @@
 </p:sld>
 </file>
 
+<file path=ppt/slides/slide10.xml><?xml version="1.0" encoding="utf-8"?>
+<p:sld xmlns:a="http://schemas.openxmlformats.org/drawingml/2006/main" xmlns:r="http://schemas.openxmlformats.org/officeDocument/2006/relationships" xmlns:p="http://schemas.openxmlformats.org/presentationml/2006/main">
+  <p:cSld name="Slide 10">
+    <p:bg>
+      <p:bgPr>
+        <a:solidFill>
+          <a:srgbClr val="0B2E31"/>
+        </a:solidFill>
+      </p:bgPr>
+    </p:bg>
+    <p:spTree>
+      <p:nvGrpSpPr>
+        <p:cNvPr id="1" name=""/>
+        <p:cNvGrpSpPr/>
+        <p:nvPr/>
+      </p:nvGrpSpPr>
+      <p:grpSpPr>
+        <a:xfrm>
+          <a:off x="0" y="0"/>
+          <a:ext cx="0" cy="0"/>
+          <a:chOff x="0" y="0"/>
+          <a:chExt cx="0" cy="0"/>
+        </a:xfrm>
+      </p:grpSpPr>
+      <p:sp>
+        <p:nvSpPr>
+          <p:cNvPr id="2" name="Text 0"/>
+          <p:cNvSpPr/>
+          <p:nvPr/>
+        </p:nvSpPr>
+        <p:spPr>
+          <a:xfrm>
+            <a:off x="640080" y="457200"/>
+            <a:ext cx="10058400" cy="640080"/>
+          </a:xfrm>
+          <a:prstGeom prst="rect">
+            <a:avLst/>
+          </a:prstGeom>
+          <a:noFill/>
+          <a:ln/>
+        </p:spPr>
+        <p:txBody>
+          <a:bodyPr wrap="square" lIns="0" tIns="0" rIns="0" bIns="0" rtlCol="0" anchor="ctr"/>
+          <a:lstStyle/>
+          <a:p>
+            <a:pPr indent="0" marL="0">
+              <a:buNone/>
+            </a:pPr>
+            <a:r>
+              <a:rPr lang="en-US" sz="3400" b="1" dirty="0">
+                <a:solidFill>
+                  <a:srgbClr val="FFFFFF"/>
+                </a:solidFill>
+                <a:latin typeface="Cambria" pitchFamily="34" charset="0"/>
+                <a:ea typeface="Cambria" pitchFamily="34" charset="-122"/>
+                <a:cs typeface="Cambria" pitchFamily="34" charset="-120"/>
+              </a:rPr>
+              <a:t>Budget &amp; Pending Decisions</a:t>
+            </a:r>
+            <a:endParaRPr lang="en-US" sz="3400" dirty="0"/>
+          </a:p>
+        </p:txBody>
+      </p:sp>
+      <p:sp>
+        <p:nvSpPr>
+          <p:cNvPr id="3" name="Text 1"/>
+          <p:cNvSpPr/>
+          <p:nvPr/>
+        </p:nvSpPr>
+        <p:spPr>
+          <a:xfrm>
+            <a:off x="640080" y="1463040"/>
+            <a:ext cx="5120640" cy="914400"/>
+          </a:xfrm>
+          <a:prstGeom prst="rect">
+            <a:avLst/>
+          </a:prstGeom>
+          <a:noFill/>
+          <a:ln/>
+        </p:spPr>
+        <p:txBody>
+          <a:bodyPr wrap="square" lIns="0" tIns="0" rIns="0" bIns="0" rtlCol="0" anchor="ctr"/>
+          <a:lstStyle/>
+          <a:p>
+            <a:pPr indent="0" marL="0">
+              <a:buNone/>
+            </a:pPr>
+            <a:r>
+              <a:rPr lang="en-US" sz="6000" b="1" dirty="0">
+                <a:solidFill>
+                  <a:srgbClr val="E07A2F"/>
+                </a:solidFill>
+                <a:latin typeface="Cambria" pitchFamily="34" charset="0"/>
+                <a:ea typeface="Cambria" pitchFamily="34" charset="-122"/>
+                <a:cs typeface="Cambria" pitchFamily="34" charset="-120"/>
+              </a:rPr>
+              <a:t>≈ $200–230</a:t>
+            </a:r>
+            <a:endParaRPr lang="en-US" sz="6000" dirty="0"/>
+          </a:p>
+        </p:txBody>
+      </p:sp>
+      <p:sp>
+        <p:nvSpPr>
+          <p:cNvPr id="4" name="Text 2"/>
+          <p:cNvSpPr/>
+          <p:nvPr/>
+        </p:nvSpPr>
+        <p:spPr>
+          <a:xfrm>
+            <a:off x="640080" y="2423160"/>
+            <a:ext cx="4937760" cy="548640"/>
+          </a:xfrm>
+          <a:prstGeom prst="rect">
+            <a:avLst/>
+          </a:prstGeom>
+          <a:noFill/>
+          <a:ln/>
+        </p:spPr>
+        <p:txBody>
+          <a:bodyPr wrap="square" lIns="0" tIns="0" rIns="0" bIns="0" rtlCol="0" anchor="ctr"/>
+          <a:lstStyle/>
+          <a:p>
+            <a:pPr indent="0" marL="0">
+              <a:buNone/>
+            </a:pPr>
+            <a:r>
+              <a:rPr lang="en-US" sz="1400" dirty="0">
+                <a:solidFill>
+                  <a:srgbClr val="9DBCBE"/>
+                </a:solidFill>
+                <a:latin typeface="Calibri" pitchFamily="34" charset="0"/>
+                <a:ea typeface="Calibri" pitchFamily="34" charset="-122"/>
+                <a:cs typeface="Calibri" pitchFamily="34" charset="-120"/>
+              </a:rPr>
+              <a:t>out of pocket with contest hardware + $300 PCBWay credit</a:t>
+            </a:r>
+            <a:endParaRPr lang="en-US" sz="1400" dirty="0"/>
+          </a:p>
+        </p:txBody>
+      </p:sp>
+      <p:sp>
+        <p:nvSpPr>
+          <p:cNvPr id="5" name="Text 3"/>
+          <p:cNvSpPr/>
+          <p:nvPr/>
+        </p:nvSpPr>
+        <p:spPr>
+          <a:xfrm>
+            <a:off x="640080" y="3200400"/>
+            <a:ext cx="5120640" cy="822960"/>
+          </a:xfrm>
+          <a:prstGeom prst="rect">
+            <a:avLst/>
+          </a:prstGeom>
+          <a:noFill/>
+          <a:ln/>
+        </p:spPr>
+        <p:txBody>
+          <a:bodyPr wrap="square" lIns="0" tIns="0" rIns="0" bIns="0" rtlCol="0" anchor="ctr"/>
+          <a:lstStyle/>
+          <a:p>
+            <a:pPr indent="0" marL="0">
+              <a:buNone/>
+            </a:pPr>
+            <a:r>
+              <a:rPr lang="en-US" sz="4000" b="1" dirty="0">
+                <a:solidFill>
+                  <a:srgbClr val="D8E4E5"/>
+                </a:solidFill>
+                <a:latin typeface="Cambria" pitchFamily="34" charset="0"/>
+                <a:ea typeface="Cambria" pitchFamily="34" charset="-122"/>
+                <a:cs typeface="Cambria" pitchFamily="34" charset="-120"/>
+              </a:rPr>
+              <a:t>≈ $450–500</a:t>
+            </a:r>
+            <a:endParaRPr lang="en-US" sz="4000" dirty="0"/>
+          </a:p>
+        </p:txBody>
+      </p:sp>
+      <p:sp>
+        <p:nvSpPr>
+          <p:cNvPr id="6" name="Text 4"/>
+          <p:cNvSpPr/>
+          <p:nvPr/>
+        </p:nvSpPr>
+        <p:spPr>
+          <a:xfrm>
+            <a:off x="640080" y="3977640"/>
+            <a:ext cx="4937760" cy="457200"/>
+          </a:xfrm>
+          <a:prstGeom prst="rect">
+            <a:avLst/>
+          </a:prstGeom>
+          <a:noFill/>
+          <a:ln/>
+        </p:spPr>
+        <p:txBody>
+          <a:bodyPr wrap="square" lIns="0" tIns="0" rIns="0" bIns="0" rtlCol="0" anchor="ctr"/>
+          <a:lstStyle/>
+          <a:p>
+            <a:pPr indent="0" marL="0">
+              <a:buNone/>
+            </a:pPr>
+            <a:r>
+              <a:rPr lang="en-US" sz="1400" dirty="0">
+                <a:solidFill>
+                  <a:srgbClr val="9DBCBE"/>
+                </a:solidFill>
+                <a:latin typeface="Calibri" pitchFamily="34" charset="0"/>
+                <a:ea typeface="Calibri" pitchFamily="34" charset="-122"/>
+                <a:cs typeface="Calibri" pitchFamily="34" charset="-120"/>
+              </a:rPr>
+              <a:t>fully self-funded worst case, + tools</a:t>
+            </a:r>
+            <a:endParaRPr lang="en-US" sz="1400" dirty="0"/>
+          </a:p>
+        </p:txBody>
+      </p:sp>
+      <p:sp>
+        <p:nvSpPr>
+          <p:cNvPr id="7" name="Shape 5"/>
+          <p:cNvSpPr/>
+          <p:nvPr/>
+        </p:nvSpPr>
+        <p:spPr>
+          <a:xfrm>
+            <a:off x="6217920" y="1463040"/>
+            <a:ext cx="5303520" cy="1371600"/>
+          </a:xfrm>
+          <a:prstGeom prst="roundRect">
+            <a:avLst>
+              <a:gd name="adj" fmla="val 5333"/>
+            </a:avLst>
+          </a:prstGeom>
+          <a:solidFill>
+            <a:srgbClr val="124145"/>
+          </a:solidFill>
+          <a:ln/>
+        </p:spPr>
+      </p:sp>
+      <p:sp>
+        <p:nvSpPr>
+          <p:cNvPr id="8" name="Text 6"/>
+          <p:cNvSpPr/>
+          <p:nvPr/>
+        </p:nvSpPr>
+        <p:spPr>
+          <a:xfrm>
+            <a:off x="6446520" y="1600200"/>
+            <a:ext cx="4846320" cy="365760"/>
+          </a:xfrm>
+          <a:prstGeom prst="rect">
+            <a:avLst/>
+          </a:prstGeom>
+          <a:noFill/>
+          <a:ln/>
+        </p:spPr>
+        <p:txBody>
+          <a:bodyPr wrap="square" lIns="0" tIns="0" rIns="0" bIns="0" rtlCol="0" anchor="ctr"/>
+          <a:lstStyle/>
+          <a:p>
+            <a:pPr indent="0" marL="0">
+              <a:buNone/>
+            </a:pPr>
+            <a:r>
+              <a:rPr lang="en-US" sz="1500" b="1" dirty="0">
+                <a:solidFill>
+                  <a:srgbClr val="E07A2F"/>
+                </a:solidFill>
+                <a:latin typeface="Calibri" pitchFamily="34" charset="0"/>
+                <a:ea typeface="Calibri" pitchFamily="34" charset="-122"/>
+                <a:cs typeface="Calibri" pitchFamily="34" charset="-120"/>
+              </a:rPr>
+              <a:t>1 · Display panel</a:t>
+            </a:r>
+            <a:endParaRPr lang="en-US" sz="1500" dirty="0"/>
+          </a:p>
+        </p:txBody>
+      </p:sp>
+      <p:sp>
+        <p:nvSpPr>
+          <p:cNvPr id="9" name="Text 7"/>
+          <p:cNvSpPr/>
+          <p:nvPr/>
+        </p:nvSpPr>
+        <p:spPr>
+          <a:xfrm>
+            <a:off x="6446520" y="1993392"/>
+            <a:ext cx="4846320" cy="777240"/>
+          </a:xfrm>
+          <a:prstGeom prst="rect">
+            <a:avLst/>
+          </a:prstGeom>
+          <a:noFill/>
+          <a:ln/>
+        </p:spPr>
+        <p:txBody>
+          <a:bodyPr wrap="square" lIns="0" tIns="0" rIns="0" bIns="0" rtlCol="0" anchor="t"/>
+          <a:lstStyle/>
+          <a:p>
+            <a:pPr indent="0" marL="0">
+              <a:buNone/>
+            </a:pPr>
+            <a:r>
+              <a:rPr lang="en-US" sz="1250" dirty="0">
+                <a:solidFill>
+                  <a:srgbClr val="D8E4E5"/>
+                </a:solidFill>
+                <a:latin typeface="Calibri" pitchFamily="34" charset="0"/>
+                <a:ea typeface="Calibri" pitchFamily="34" charset="-122"/>
+                <a:cs typeface="Calibri" pitchFamily="34" charset="-120"/>
+              </a:rPr>
+              <a:t>4a decided; exact DSI panel selection due — blocks battery, enclosure, renderer. Fallback gate Sep 30.</a:t>
+            </a:r>
+            <a:endParaRPr lang="en-US" sz="1250" dirty="0"/>
+          </a:p>
+        </p:txBody>
+      </p:sp>
+      <p:sp>
+        <p:nvSpPr>
+          <p:cNvPr id="10" name="Shape 8"/>
+          <p:cNvSpPr/>
+          <p:nvPr/>
+        </p:nvSpPr>
+        <p:spPr>
+          <a:xfrm>
+            <a:off x="6217920" y="3017520"/>
+            <a:ext cx="5303520" cy="1371600"/>
+          </a:xfrm>
+          <a:prstGeom prst="roundRect">
+            <a:avLst>
+              <a:gd name="adj" fmla="val 5333"/>
+            </a:avLst>
+          </a:prstGeom>
+          <a:solidFill>
+            <a:srgbClr val="124145"/>
+          </a:solidFill>
+          <a:ln/>
+        </p:spPr>
+      </p:sp>
+      <p:sp>
+        <p:nvSpPr>
+          <p:cNvPr id="11" name="Text 9"/>
+          <p:cNvSpPr/>
+          <p:nvPr/>
+        </p:nvSpPr>
+        <p:spPr>
+          <a:xfrm>
+            <a:off x="6446520" y="3154680"/>
+            <a:ext cx="4846320" cy="365760"/>
+          </a:xfrm>
+          <a:prstGeom prst="rect">
+            <a:avLst/>
+          </a:prstGeom>
+          <a:noFill/>
+          <a:ln/>
+        </p:spPr>
+        <p:txBody>
+          <a:bodyPr wrap="square" lIns="0" tIns="0" rIns="0" bIns="0" rtlCol="0" anchor="ctr"/>
+          <a:lstStyle/>
+          <a:p>
+            <a:pPr indent="0" marL="0">
+              <a:buNone/>
+            </a:pPr>
+            <a:r>
+              <a:rPr lang="en-US" sz="1500" b="1" dirty="0">
+                <a:solidFill>
+                  <a:srgbClr val="E07A2F"/>
+                </a:solidFill>
+                <a:latin typeface="Calibri" pitchFamily="34" charset="0"/>
+                <a:ea typeface="Calibri" pitchFamily="34" charset="-122"/>
+                <a:cs typeface="Calibri" pitchFamily="34" charset="-120"/>
+              </a:rPr>
+              <a:t>2 · Camera 7a vs 7b</a:t>
+            </a:r>
+            <a:endParaRPr lang="en-US" sz="1500" dirty="0"/>
+          </a:p>
+        </p:txBody>
+      </p:sp>
+      <p:sp>
+        <p:nvSpPr>
+          <p:cNvPr id="12" name="Text 10"/>
+          <p:cNvSpPr/>
+          <p:nvPr/>
+        </p:nvSpPr>
+        <p:spPr>
+          <a:xfrm>
+            <a:off x="6446520" y="3547872"/>
+            <a:ext cx="4846320" cy="777240"/>
+          </a:xfrm>
+          <a:prstGeom prst="rect">
+            <a:avLst/>
+          </a:prstGeom>
+          <a:noFill/>
+          <a:ln/>
+        </p:spPr>
+        <p:txBody>
+          <a:bodyPr wrap="square" lIns="0" tIns="0" rIns="0" bIns="0" rtlCol="0" anchor="t"/>
+          <a:lstStyle/>
+          <a:p>
+            <a:pPr indent="0" marL="0">
+              <a:buNone/>
+            </a:pPr>
+            <a:r>
+              <a:rPr lang="en-US" sz="1250" dirty="0">
+                <a:solidFill>
+                  <a:srgbClr val="D8E4E5"/>
+                </a:solidFill>
+                <a:latin typeface="Calibri" pitchFamily="34" charset="0"/>
+                <a:ea typeface="Calibri" pitchFamily="34" charset="-122"/>
+                <a:cs typeface="Calibri" pitchFamily="34" charset="-120"/>
+              </a:rPr>
+              <a:t>Blocked on confirming UNO Q camera input paths (UVC vs CSI).</a:t>
+            </a:r>
+            <a:endParaRPr lang="en-US" sz="1250" dirty="0"/>
+          </a:p>
+        </p:txBody>
+      </p:sp>
+      <p:sp>
+        <p:nvSpPr>
+          <p:cNvPr id="13" name="Shape 11"/>
+          <p:cNvSpPr/>
+          <p:nvPr/>
+        </p:nvSpPr>
+        <p:spPr>
+          <a:xfrm>
+            <a:off x="6217920" y="4572000"/>
+            <a:ext cx="5303520" cy="1371600"/>
+          </a:xfrm>
+          <a:prstGeom prst="roundRect">
+            <a:avLst>
+              <a:gd name="adj" fmla="val 5333"/>
+            </a:avLst>
+          </a:prstGeom>
+          <a:solidFill>
+            <a:srgbClr val="124145"/>
+          </a:solidFill>
+          <a:ln/>
+        </p:spPr>
+      </p:sp>
+      <p:sp>
+        <p:nvSpPr>
+          <p:cNvPr id="14" name="Text 12"/>
+          <p:cNvSpPr/>
+          <p:nvPr/>
+        </p:nvSpPr>
+        <p:spPr>
+          <a:xfrm>
+            <a:off x="6446520" y="4709160"/>
+            <a:ext cx="4846320" cy="365760"/>
+          </a:xfrm>
+          <a:prstGeom prst="rect">
+            <a:avLst/>
+          </a:prstGeom>
+          <a:noFill/>
+          <a:ln/>
+        </p:spPr>
+        <p:txBody>
+          <a:bodyPr wrap="square" lIns="0" tIns="0" rIns="0" bIns="0" rtlCol="0" anchor="ctr"/>
+          <a:lstStyle/>
+          <a:p>
+            <a:pPr indent="0" marL="0">
+              <a:buNone/>
+            </a:pPr>
+            <a:r>
+              <a:rPr lang="en-US" sz="1500" b="1" dirty="0">
+                <a:solidFill>
+                  <a:srgbClr val="E07A2F"/>
+                </a:solidFill>
+                <a:latin typeface="Calibri" pitchFamily="34" charset="0"/>
+                <a:ea typeface="Calibri" pitchFamily="34" charset="-122"/>
+                <a:cs typeface="Calibri" pitchFamily="34" charset="-120"/>
+              </a:rPr>
+              <a:t>3 · ToF 8a/8b · IMU 9a/9b</a:t>
+            </a:r>
+            <a:endParaRPr lang="en-US" sz="1500" dirty="0"/>
+          </a:p>
+        </p:txBody>
+      </p:sp>
+      <p:sp>
+        <p:nvSpPr>
+          <p:cNvPr id="15" name="Text 13"/>
+          <p:cNvSpPr/>
+          <p:nvPr/>
+        </p:nvSpPr>
+        <p:spPr>
+          <a:xfrm>
+            <a:off x="6446520" y="5102352"/>
+            <a:ext cx="4846320" cy="777240"/>
+          </a:xfrm>
+          <a:prstGeom prst="rect">
+            <a:avLst/>
+          </a:prstGeom>
+          <a:noFill/>
+          <a:ln/>
+        </p:spPr>
+        <p:txBody>
+          <a:bodyPr wrap="square" lIns="0" tIns="0" rIns="0" bIns="0" rtlCol="0" anchor="t"/>
+          <a:lstStyle/>
+          <a:p>
+            <a:pPr indent="0" marL="0">
+              <a:buNone/>
+            </a:pPr>
+            <a:r>
+              <a:rPr lang="en-US" sz="1250" dirty="0">
+                <a:solidFill>
+                  <a:srgbClr val="D8E4E5"/>
+                </a:solidFill>
+                <a:latin typeface="Calibri" pitchFamily="34" charset="0"/>
+                <a:ea typeface="Calibri" pitchFamily="34" charset="-122"/>
+                <a:cs typeface="Calibri" pitchFamily="34" charset="-120"/>
+              </a:rPr>
+              <a:t>Analysis pending. I²C either way — doesn't block carrier PCB schematic start.</a:t>
+            </a:r>
+            <a:endParaRPr lang="en-US" sz="1250" dirty="0"/>
+          </a:p>
+        </p:txBody>
+      </p:sp>
+      <p:sp>
+        <p:nvSpPr>
+          <p:cNvPr id="16" name="Text 14"/>
+          <p:cNvSpPr/>
+          <p:nvPr/>
+        </p:nvSpPr>
+        <p:spPr>
+          <a:xfrm>
+            <a:off x="640080" y="6126480"/>
+            <a:ext cx="10515600" cy="365760"/>
+          </a:xfrm>
+          <a:prstGeom prst="rect">
+            <a:avLst/>
+          </a:prstGeom>
+          <a:noFill/>
+          <a:ln/>
+        </p:spPr>
+        <p:txBody>
+          <a:bodyPr wrap="square" lIns="0" tIns="0" rIns="0" bIns="0" rtlCol="0" anchor="ctr"/>
+          <a:lstStyle/>
+          <a:p>
+            <a:pPr indent="0" marL="0">
+              <a:buNone/>
+            </a:pPr>
+            <a:r>
+              <a:rPr lang="en-US" sz="1250" i="1" dirty="0">
+                <a:solidFill>
+                  <a:srgbClr val="6E9598"/>
+                </a:solidFill>
+                <a:latin typeface="Calibri" pitchFamily="34" charset="0"/>
+                <a:ea typeface="Calibri" pitchFamily="34" charset="-122"/>
+                <a:cs typeface="Calibri" pitchFamily="34" charset="-120"/>
+              </a:rPr>
+              <a:t>Alternates are kept deliberately — no option is deleted without a decision note.</a:t>
+            </a:r>
+            <a:endParaRPr lang="en-US" sz="1250" dirty="0"/>
+          </a:p>
+        </p:txBody>
+      </p:sp>
+    </p:spTree>
+  </p:cSld>
+  <p:clrMapOvr>
+    <a:masterClrMapping/>
+  </p:clrMapOvr>
+</p:sld>
+</file>
+
 <file path=ppt/slides/slide2.xml><?xml version="1.0" encoding="utf-8"?>
 <p:sld xmlns:a="http://schemas.openxmlformats.org/drawingml/2006/main" xmlns:r="http://schemas.openxmlformats.org/officeDocument/2006/relationships" xmlns:p="http://schemas.openxmlformats.org/presentationml/2006/main">
   <p:cSld name="Slide 2">
@@ -4042,7 +4697,7 @@
                 <a:ea typeface="Cambria" pitchFamily="34" charset="-122"/>
                 <a:cs typeface="Cambria" pitchFamily="34" charset="-120"/>
               </a:rPr>
-              <a:t>Input, Aux Sensing &amp; Feedback</a:t>
+              <a:t>Rotary Encoder — 5a / 5b / 5c</a:t>
             </a:r>
             <a:endParaRPr lang="en-US" sz="3200" dirty="0"/>
           </a:p>
@@ -4081,7 +4736,7 @@
                 <a:ea typeface="Calibri" pitchFamily="34" charset="-122"/>
                 <a:cs typeface="Calibri" pitchFamily="34" charset="-120"/>
               </a:rPr>
-              <a:t>Settled commodity parts — no open decisions here</a:t>
+              <a:t>Primary nav control at left thumb — BOM currently lists EC11 only; alternates added for consideration</a:t>
             </a:r>
             <a:endParaRPr lang="en-US" sz="1450" dirty="0"/>
           </a:p>
@@ -4103,8 +4758,8 @@
         </p:blipFill>
         <p:spPr>
           <a:xfrm>
-            <a:off x="8412480" y="1737360"/>
-            <a:ext cx="2926080" cy="2423160"/>
+            <a:off x="8503920" y="1783080"/>
+            <a:ext cx="2834640" cy="2331720"/>
           </a:xfrm>
           <a:prstGeom prst="rect">
             <a:avLst/>
@@ -4113,14 +4768,75 @@
       </p:pic>
       <p:sp>
         <p:nvSpPr>
-          <p:cNvPr id="5" name="Text 2"/>
-          <p:cNvSpPr/>
-          <p:nvPr/>
-        </p:nvSpPr>
-        <p:spPr>
-          <a:xfrm>
-            <a:off x="640080" y="1783080"/>
-            <a:ext cx="1737360" cy="566928"/>
+          <p:cNvPr id="5" name="Shape 2"/>
+          <p:cNvSpPr/>
+          <p:nvPr/>
+        </p:nvSpPr>
+        <p:spPr>
+          <a:xfrm>
+            <a:off x="640080" y="1737360"/>
+            <a:ext cx="7498080" cy="1371600"/>
+          </a:xfrm>
+          <a:prstGeom prst="roundRect">
+            <a:avLst>
+              <a:gd name="adj" fmla="val 4667"/>
+            </a:avLst>
+          </a:prstGeom>
+          <a:solidFill>
+            <a:srgbClr val="E7F2EC"/>
+          </a:solidFill>
+          <a:ln/>
+        </p:spPr>
+      </p:sp>
+      <p:sp>
+        <p:nvSpPr>
+          <p:cNvPr id="6" name="Text 3"/>
+          <p:cNvSpPr/>
+          <p:nvPr/>
+        </p:nvSpPr>
+        <p:spPr>
+          <a:xfrm>
+            <a:off x="841248" y="1847088"/>
+            <a:ext cx="7095744" cy="320040"/>
+          </a:xfrm>
+          <a:prstGeom prst="rect">
+            <a:avLst/>
+          </a:prstGeom>
+          <a:noFill/>
+          <a:ln/>
+        </p:spPr>
+        <p:txBody>
+          <a:bodyPr wrap="square" lIns="0" tIns="0" rIns="0" bIns="0" rtlCol="0" anchor="ctr"/>
+          <a:lstStyle/>
+          <a:p>
+            <a:pPr indent="0" marL="0">
+              <a:buNone/>
+            </a:pPr>
+            <a:r>
+              <a:rPr lang="en-US" sz="1350" b="1" dirty="0">
+                <a:solidFill>
+                  <a:srgbClr val="1E6B45"/>
+                </a:solidFill>
+                <a:latin typeface="Calibri" pitchFamily="34" charset="0"/>
+                <a:ea typeface="Calibri" pitchFamily="34" charset="-122"/>
+                <a:cs typeface="Calibri" pitchFamily="34" charset="-120"/>
+              </a:rPr>
+              <a:t>5a — EC11 mechanical, detented, w/ push (e.g. Bourns PEC11R) · $3 · ✦ primary</a:t>
+            </a:r>
+            <a:endParaRPr lang="en-US" sz="1350" dirty="0"/>
+          </a:p>
+        </p:txBody>
+      </p:sp>
+      <p:sp>
+        <p:nvSpPr>
+          <p:cNvPr id="7" name="Text 4"/>
+          <p:cNvSpPr/>
+          <p:nvPr/>
+        </p:nvSpPr>
+        <p:spPr>
+          <a:xfrm>
+            <a:off x="841248" y="2194560"/>
+            <a:ext cx="7095744" cy="804672"/>
           </a:xfrm>
           <a:prstGeom prst="rect">
             <a:avLst/>
@@ -4136,7 +4852,68 @@
               <a:buNone/>
             </a:pPr>
             <a:r>
-              <a:rPr lang="en-US" sz="1250" b="1" dirty="0">
+              <a:rPr lang="en-US" sz="1150" dirty="0">
+                <a:solidFill>
+                  <a:srgbClr val="12262A"/>
+                </a:solidFill>
+                <a:latin typeface="Calibri" pitchFamily="34" charset="0"/>
+                <a:ea typeface="Calibri" pitchFamily="34" charset="-122"/>
+                <a:cs typeface="Calibri" pitchFamily="34" charset="-120"/>
+              </a:rPr>
+              <a:t>24 detents give free tactile feedback, integrated push = select, threaded bushing panel-mounts cleanly into the grip. Proven, cheap, zero driver work — just debounce. Contact wear is the only real weakness.</a:t>
+            </a:r>
+            <a:endParaRPr lang="en-US" sz="1150" dirty="0"/>
+          </a:p>
+        </p:txBody>
+      </p:sp>
+      <p:sp>
+        <p:nvSpPr>
+          <p:cNvPr id="8" name="Shape 5"/>
+          <p:cNvSpPr/>
+          <p:nvPr/>
+        </p:nvSpPr>
+        <p:spPr>
+          <a:xfrm>
+            <a:off x="640080" y="3291840"/>
+            <a:ext cx="7498080" cy="1371600"/>
+          </a:xfrm>
+          <a:prstGeom prst="roundRect">
+            <a:avLst>
+              <a:gd name="adj" fmla="val 4667"/>
+            </a:avLst>
+          </a:prstGeom>
+          <a:solidFill>
+            <a:srgbClr val="EEF4F4"/>
+          </a:solidFill>
+          <a:ln/>
+        </p:spPr>
+      </p:sp>
+      <p:sp>
+        <p:nvSpPr>
+          <p:cNvPr id="9" name="Text 6"/>
+          <p:cNvSpPr/>
+          <p:nvPr/>
+        </p:nvSpPr>
+        <p:spPr>
+          <a:xfrm>
+            <a:off x="841248" y="3401568"/>
+            <a:ext cx="7095744" cy="320040"/>
+          </a:xfrm>
+          <a:prstGeom prst="rect">
+            <a:avLst/>
+          </a:prstGeom>
+          <a:noFill/>
+          <a:ln/>
+        </p:spPr>
+        <p:txBody>
+          <a:bodyPr wrap="square" lIns="0" tIns="0" rIns="0" bIns="0" rtlCol="0" anchor="ctr"/>
+          <a:lstStyle/>
+          <a:p>
+            <a:pPr indent="0" marL="0">
+              <a:buNone/>
+            </a:pPr>
+            <a:r>
+              <a:rPr lang="en-US" sz="1350" b="1" dirty="0">
                 <a:solidFill>
                   <a:srgbClr val="0E5E63"/>
                 </a:solidFill>
@@ -4144,22 +4921,22 @@
                 <a:ea typeface="Calibri" pitchFamily="34" charset="-122"/>
                 <a:cs typeface="Calibri" pitchFamily="34" charset="-120"/>
               </a:rPr>
-              <a:t>Encoder</a:t>
-            </a:r>
-            <a:endParaRPr lang="en-US" sz="1250" dirty="0"/>
-          </a:p>
-        </p:txBody>
-      </p:sp>
-      <p:sp>
-        <p:nvSpPr>
-          <p:cNvPr id="6" name="Text 3"/>
-          <p:cNvSpPr/>
-          <p:nvPr/>
-        </p:nvSpPr>
-        <p:spPr>
-          <a:xfrm>
-            <a:off x="2468880" y="1783080"/>
-            <a:ext cx="5760720" cy="566928"/>
+              <a:t>5b — Magnetic: AS5600 + magnet shaft · ~$8</a:t>
+            </a:r>
+            <a:endParaRPr lang="en-US" sz="1350" dirty="0"/>
+          </a:p>
+        </p:txBody>
+      </p:sp>
+      <p:sp>
+        <p:nvSpPr>
+          <p:cNvPr id="10" name="Text 7"/>
+          <p:cNvSpPr/>
+          <p:nvPr/>
+        </p:nvSpPr>
+        <p:spPr>
+          <a:xfrm>
+            <a:off x="841248" y="3749040"/>
+            <a:ext cx="7095744" cy="804672"/>
           </a:xfrm>
           <a:prstGeom prst="rect">
             <a:avLst/>
@@ -4175,7 +4952,7 @@
               <a:buNone/>
             </a:pPr>
             <a:r>
-              <a:rPr lang="en-US" sz="1250" dirty="0">
+              <a:rPr lang="en-US" sz="1150" dirty="0">
                 <a:solidFill>
                   <a:srgbClr val="12262A"/>
                 </a:solidFill>
@@ -4183,22 +4960,83 @@
                 <a:ea typeface="Calibri" pitchFamily="34" charset="-122"/>
                 <a:cs typeface="Calibri" pitchFamily="34" charset="-120"/>
               </a:rPr>
-              <a:t>EC11-style rotary w/ push, $3 — primary nav, at left thumb per ID doc</a:t>
-            </a:r>
-            <a:endParaRPr lang="en-US" sz="1250" dirty="0"/>
-          </a:p>
-        </p:txBody>
-      </p:sp>
-      <p:sp>
-        <p:nvSpPr>
-          <p:cNvPr id="7" name="Text 4"/>
-          <p:cNvSpPr/>
-          <p:nvPr/>
-        </p:nvSpPr>
-        <p:spPr>
-          <a:xfrm>
-            <a:off x="640080" y="2350008"/>
-            <a:ext cx="1737360" cy="566928"/>
+              <a:t>Contactless — smooth continuous rotation, no bounce, no wear, absolute position. I²C, so it drops straight onto the carrier hub. No detents and no push: needs a separate tactile for select, and “clicks” would come from the haptic motor (pairs with item 17).</a:t>
+            </a:r>
+            <a:endParaRPr lang="en-US" sz="1150" dirty="0"/>
+          </a:p>
+        </p:txBody>
+      </p:sp>
+      <p:sp>
+        <p:nvSpPr>
+          <p:cNvPr id="11" name="Shape 8"/>
+          <p:cNvSpPr/>
+          <p:nvPr/>
+        </p:nvSpPr>
+        <p:spPr>
+          <a:xfrm>
+            <a:off x="640080" y="4846320"/>
+            <a:ext cx="7498080" cy="1371600"/>
+          </a:xfrm>
+          <a:prstGeom prst="roundRect">
+            <a:avLst>
+              <a:gd name="adj" fmla="val 4667"/>
+            </a:avLst>
+          </a:prstGeom>
+          <a:solidFill>
+            <a:srgbClr val="EEF4F4"/>
+          </a:solidFill>
+          <a:ln/>
+        </p:spPr>
+      </p:sp>
+      <p:sp>
+        <p:nvSpPr>
+          <p:cNvPr id="12" name="Text 9"/>
+          <p:cNvSpPr/>
+          <p:nvPr/>
+        </p:nvSpPr>
+        <p:spPr>
+          <a:xfrm>
+            <a:off x="841248" y="4956048"/>
+            <a:ext cx="7095744" cy="320040"/>
+          </a:xfrm>
+          <a:prstGeom prst="rect">
+            <a:avLst/>
+          </a:prstGeom>
+          <a:noFill/>
+          <a:ln/>
+        </p:spPr>
+        <p:txBody>
+          <a:bodyPr wrap="square" lIns="0" tIns="0" rIns="0" bIns="0" rtlCol="0" anchor="ctr"/>
+          <a:lstStyle/>
+          <a:p>
+            <a:pPr indent="0" marL="0">
+              <a:buNone/>
+            </a:pPr>
+            <a:r>
+              <a:rPr lang="en-US" sz="1350" b="1" dirty="0">
+                <a:solidFill>
+                  <a:srgbClr val="0E5E63"/>
+                </a:solidFill>
+                <a:latin typeface="Calibri" pitchFamily="34" charset="0"/>
+                <a:ea typeface="Calibri" pitchFamily="34" charset="-122"/>
+                <a:cs typeface="Calibri" pitchFamily="34" charset="-120"/>
+              </a:rPr>
+              <a:t>5c — Adafruit ANO directional nav encoder (P/N 5001) · $9</a:t>
+            </a:r>
+            <a:endParaRPr lang="en-US" sz="1350" dirty="0"/>
+          </a:p>
+        </p:txBody>
+      </p:sp>
+      <p:sp>
+        <p:nvSpPr>
+          <p:cNvPr id="13" name="Text 10"/>
+          <p:cNvSpPr/>
+          <p:nvPr/>
+        </p:nvSpPr>
+        <p:spPr>
+          <a:xfrm>
+            <a:off x="841248" y="5303520"/>
+            <a:ext cx="7095744" cy="804672"/>
           </a:xfrm>
           <a:prstGeom prst="rect">
             <a:avLst/>
@@ -4214,7 +5052,68 @@
               <a:buNone/>
             </a:pPr>
             <a:r>
-              <a:rPr lang="en-US" sz="1250" b="1" dirty="0">
+              <a:rPr lang="en-US" sz="1150" dirty="0">
+                <a:solidFill>
+                  <a:srgbClr val="12262A"/>
+                </a:solidFill>
+                <a:latin typeface="Calibri" pitchFamily="34" charset="0"/>
+                <a:ea typeface="Calibri" pitchFamily="34" charset="-122"/>
+                <a:cs typeface="Calibri" pitchFamily="34" charset="-120"/>
+              </a:rPr>
+              <a:t>Scroll wheel + 5-way buttons in one iPod-style part — could replace the encoder AND the 4 tactile function keys (item 6), simplifying the front face. Larger footprint; commits the UI to wheel-centric navigation.</a:t>
+            </a:r>
+            <a:endParaRPr lang="en-US" sz="1150" dirty="0"/>
+          </a:p>
+        </p:txBody>
+      </p:sp>
+      <p:sp>
+        <p:nvSpPr>
+          <p:cNvPr id="14" name="Shape 11"/>
+          <p:cNvSpPr/>
+          <p:nvPr/>
+        </p:nvSpPr>
+        <p:spPr>
+          <a:xfrm>
+            <a:off x="8503920" y="4343400"/>
+            <a:ext cx="3063240" cy="1783080"/>
+          </a:xfrm>
+          <a:prstGeom prst="roundRect">
+            <a:avLst>
+              <a:gd name="adj" fmla="val 3590"/>
+            </a:avLst>
+          </a:prstGeom>
+          <a:solidFill>
+            <a:srgbClr val="EEF4F4"/>
+          </a:solidFill>
+          <a:ln/>
+        </p:spPr>
+      </p:sp>
+      <p:sp>
+        <p:nvSpPr>
+          <p:cNvPr id="15" name="Text 12"/>
+          <p:cNvSpPr/>
+          <p:nvPr/>
+        </p:nvSpPr>
+        <p:spPr>
+          <a:xfrm>
+            <a:off x="8705088" y="4498848"/>
+            <a:ext cx="2651760" cy="1554480"/>
+          </a:xfrm>
+          <a:prstGeom prst="rect">
+            <a:avLst/>
+          </a:prstGeom>
+          <a:noFill/>
+          <a:ln/>
+        </p:spPr>
+        <p:txBody>
+          <a:bodyPr wrap="square" lIns="0" tIns="0" rIns="0" bIns="0" rtlCol="0" anchor="t"/>
+          <a:lstStyle/>
+          <a:p>
+            <a:pPr indent="0" marL="0">
+              <a:buNone/>
+            </a:pPr>
+            <a:r>
+              <a:rPr lang="en-US" sz="1150" b="1" dirty="0">
                 <a:solidFill>
                   <a:srgbClr val="0E5E63"/>
                 </a:solidFill>
@@ -4222,38 +5121,16 @@
                 <a:ea typeface="Calibri" pitchFamily="34" charset="-122"/>
                 <a:cs typeface="Calibri" pitchFamily="34" charset="-120"/>
               </a:rPr>
-              <a:t>Buttons</a:t>
-            </a:r>
-            <a:endParaRPr lang="en-US" sz="1250" dirty="0"/>
-          </a:p>
-        </p:txBody>
-      </p:sp>
-      <p:sp>
-        <p:nvSpPr>
-          <p:cNvPr id="8" name="Text 5"/>
-          <p:cNvSpPr/>
-          <p:nvPr/>
-        </p:nvSpPr>
-        <p:spPr>
-          <a:xfrm>
-            <a:off x="2468880" y="2350008"/>
-            <a:ext cx="5760720" cy="566928"/>
-          </a:xfrm>
-          <a:prstGeom prst="rect">
-            <a:avLst/>
-          </a:prstGeom>
-          <a:noFill/>
-          <a:ln/>
-        </p:spPr>
-        <p:txBody>
-          <a:bodyPr wrap="square" lIns="0" tIns="0" rIns="0" bIns="0" rtlCol="0" anchor="t"/>
-          <a:lstStyle/>
-          <a:p>
-            <a:pPr indent="0" marL="0">
-              <a:buNone/>
-            </a:pPr>
-            <a:r>
-              <a:rPr lang="en-US" sz="1250" dirty="0">
+              <a:t>Decision driver: </a:t>
+            </a:r>
+            <a:endParaRPr lang="en-US" sz="1150" dirty="0"/>
+          </a:p>
+          <a:p>
+            <a:pPr indent="0" marL="0">
+              <a:buNone/>
+            </a:pPr>
+            <a:r>
+              <a:rPr lang="en-US" sz="1150" dirty="0">
                 <a:solidFill>
                   <a:srgbClr val="12262A"/>
                 </a:solidFill>
@@ -4261,399 +5138,9 @@
                 <a:ea typeface="Calibri" pitchFamily="34" charset="-122"/>
                 <a:cs typeface="Calibri" pitchFamily="34" charset="-120"/>
               </a:rPr>
-              <a:t>4× 6 mm tactile, $2 — trigger + function keys</a:t>
-            </a:r>
-            <a:endParaRPr lang="en-US" sz="1250" dirty="0"/>
-          </a:p>
-        </p:txBody>
-      </p:sp>
-      <p:sp>
-        <p:nvSpPr>
-          <p:cNvPr id="9" name="Text 6"/>
-          <p:cNvSpPr/>
-          <p:nvPr/>
-        </p:nvSpPr>
-        <p:spPr>
-          <a:xfrm>
-            <a:off x="640080" y="2916936"/>
-            <a:ext cx="1737360" cy="566928"/>
-          </a:xfrm>
-          <a:prstGeom prst="rect">
-            <a:avLst/>
-          </a:prstGeom>
-          <a:noFill/>
-          <a:ln/>
-        </p:spPr>
-        <p:txBody>
-          <a:bodyPr wrap="square" lIns="0" tIns="0" rIns="0" bIns="0" rtlCol="0" anchor="t"/>
-          <a:lstStyle/>
-          <a:p>
-            <a:pPr indent="0" marL="0">
-              <a:buNone/>
-            </a:pPr>
-            <a:r>
-              <a:rPr lang="en-US" sz="1250" b="1" dirty="0">
-                <a:solidFill>
-                  <a:srgbClr val="0E5E63"/>
-                </a:solidFill>
-                <a:latin typeface="Calibri" pitchFamily="34" charset="0"/>
-                <a:ea typeface="Calibri" pitchFamily="34" charset="-122"/>
-                <a:cs typeface="Calibri" pitchFamily="34" charset="-120"/>
-              </a:rPr>
-              <a:t>Color</a:t>
-            </a:r>
-            <a:endParaRPr lang="en-US" sz="1250" dirty="0"/>
-          </a:p>
-        </p:txBody>
-      </p:sp>
-      <p:sp>
-        <p:nvSpPr>
-          <p:cNvPr id="10" name="Text 7"/>
-          <p:cNvSpPr/>
-          <p:nvPr/>
-        </p:nvSpPr>
-        <p:spPr>
-          <a:xfrm>
-            <a:off x="2468880" y="2916936"/>
-            <a:ext cx="5760720" cy="566928"/>
-          </a:xfrm>
-          <a:prstGeom prst="rect">
-            <a:avLst/>
-          </a:prstGeom>
-          <a:noFill/>
-          <a:ln/>
-        </p:spPr>
-        <p:txBody>
-          <a:bodyPr wrap="square" lIns="0" tIns="0" rIns="0" bIns="0" rtlCol="0" anchor="t"/>
-          <a:lstStyle/>
-          <a:p>
-            <a:pPr indent="0" marL="0">
-              <a:buNone/>
-            </a:pPr>
-            <a:r>
-              <a:rPr lang="en-US" sz="1250" dirty="0">
-                <a:solidFill>
-                  <a:srgbClr val="12262A"/>
-                </a:solidFill>
-                <a:latin typeface="Calibri" pitchFamily="34" charset="0"/>
-                <a:ea typeface="Calibri" pitchFamily="34" charset="-122"/>
-                <a:cs typeface="Calibri" pitchFamily="34" charset="-120"/>
-              </a:rPr>
-              <a:t>TCS34725, $8 — multi-measure lineage feature</a:t>
-            </a:r>
-            <a:endParaRPr lang="en-US" sz="1250" dirty="0"/>
-          </a:p>
-        </p:txBody>
-      </p:sp>
-      <p:sp>
-        <p:nvSpPr>
-          <p:cNvPr id="11" name="Text 8"/>
-          <p:cNvSpPr/>
-          <p:nvPr/>
-        </p:nvSpPr>
-        <p:spPr>
-          <a:xfrm>
-            <a:off x="640080" y="3483864"/>
-            <a:ext cx="1737360" cy="566928"/>
-          </a:xfrm>
-          <a:prstGeom prst="rect">
-            <a:avLst/>
-          </a:prstGeom>
-          <a:noFill/>
-          <a:ln/>
-        </p:spPr>
-        <p:txBody>
-          <a:bodyPr wrap="square" lIns="0" tIns="0" rIns="0" bIns="0" rtlCol="0" anchor="t"/>
-          <a:lstStyle/>
-          <a:p>
-            <a:pPr indent="0" marL="0">
-              <a:buNone/>
-            </a:pPr>
-            <a:r>
-              <a:rPr lang="en-US" sz="1250" b="1" dirty="0">
-                <a:solidFill>
-                  <a:srgbClr val="0E5E63"/>
-                </a:solidFill>
-                <a:latin typeface="Calibri" pitchFamily="34" charset="0"/>
-                <a:ea typeface="Calibri" pitchFamily="34" charset="-122"/>
-                <a:cs typeface="Calibri" pitchFamily="34" charset="-120"/>
-              </a:rPr>
-              <a:t>Illumination</a:t>
-            </a:r>
-            <a:endParaRPr lang="en-US" sz="1250" dirty="0"/>
-          </a:p>
-        </p:txBody>
-      </p:sp>
-      <p:sp>
-        <p:nvSpPr>
-          <p:cNvPr id="12" name="Text 9"/>
-          <p:cNvSpPr/>
-          <p:nvPr/>
-        </p:nvSpPr>
-        <p:spPr>
-          <a:xfrm>
-            <a:off x="2468880" y="3483864"/>
-            <a:ext cx="5760720" cy="566928"/>
-          </a:xfrm>
-          <a:prstGeom prst="rect">
-            <a:avLst/>
-          </a:prstGeom>
-          <a:noFill/>
-          <a:ln/>
-        </p:spPr>
-        <p:txBody>
-          <a:bodyPr wrap="square" lIns="0" tIns="0" rIns="0" bIns="0" rtlCol="0" anchor="t"/>
-          <a:lstStyle/>
-          <a:p>
-            <a:pPr indent="0" marL="0">
-              <a:buNone/>
-            </a:pPr>
-            <a:r>
-              <a:rPr lang="en-US" sz="1250" dirty="0">
-                <a:solidFill>
-                  <a:srgbClr val="12262A"/>
-                </a:solidFill>
-                <a:latin typeface="Calibri" pitchFamily="34" charset="0"/>
-                <a:ea typeface="Calibri" pitchFamily="34" charset="-122"/>
-                <a:cs typeface="Calibri" pitchFamily="34" charset="-120"/>
-              </a:rPr>
-              <a:t>2× high-CRI white LED + driver, $2 — controlled shadow casting</a:t>
-            </a:r>
-            <a:endParaRPr lang="en-US" sz="1250" dirty="0"/>
-          </a:p>
-        </p:txBody>
-      </p:sp>
-      <p:sp>
-        <p:nvSpPr>
-          <p:cNvPr id="13" name="Text 10"/>
-          <p:cNvSpPr/>
-          <p:nvPr/>
-        </p:nvSpPr>
-        <p:spPr>
-          <a:xfrm>
-            <a:off x="640080" y="4050792"/>
-            <a:ext cx="1737360" cy="566928"/>
-          </a:xfrm>
-          <a:prstGeom prst="rect">
-            <a:avLst/>
-          </a:prstGeom>
-          <a:noFill/>
-          <a:ln/>
-        </p:spPr>
-        <p:txBody>
-          <a:bodyPr wrap="square" lIns="0" tIns="0" rIns="0" bIns="0" rtlCol="0" anchor="t"/>
-          <a:lstStyle/>
-          <a:p>
-            <a:pPr indent="0" marL="0">
-              <a:buNone/>
-            </a:pPr>
-            <a:r>
-              <a:rPr lang="en-US" sz="1250" b="1" dirty="0">
-                <a:solidFill>
-                  <a:srgbClr val="0E5E63"/>
-                </a:solidFill>
-                <a:latin typeface="Calibri" pitchFamily="34" charset="0"/>
-                <a:ea typeface="Calibri" pitchFamily="34" charset="-122"/>
-                <a:cs typeface="Calibri" pitchFamily="34" charset="-120"/>
-              </a:rPr>
-              <a:t>Audio</a:t>
-            </a:r>
-            <a:endParaRPr lang="en-US" sz="1250" dirty="0"/>
-          </a:p>
-        </p:txBody>
-      </p:sp>
-      <p:sp>
-        <p:nvSpPr>
-          <p:cNvPr id="14" name="Text 11"/>
-          <p:cNvSpPr/>
-          <p:nvPr/>
-        </p:nvSpPr>
-        <p:spPr>
-          <a:xfrm>
-            <a:off x="2468880" y="4050792"/>
-            <a:ext cx="5760720" cy="566928"/>
-          </a:xfrm>
-          <a:prstGeom prst="rect">
-            <a:avLst/>
-          </a:prstGeom>
-          <a:noFill/>
-          <a:ln/>
-        </p:spPr>
-        <p:txBody>
-          <a:bodyPr wrap="square" lIns="0" tIns="0" rIns="0" bIns="0" rtlCol="0" anchor="t"/>
-          <a:lstStyle/>
-          <a:p>
-            <a:pPr indent="0" marL="0">
-              <a:buNone/>
-            </a:pPr>
-            <a:r>
-              <a:rPr lang="en-US" sz="1250" dirty="0">
-                <a:solidFill>
-                  <a:srgbClr val="12262A"/>
-                </a:solidFill>
-                <a:latin typeface="Calibri" pitchFamily="34" charset="0"/>
-                <a:ea typeface="Calibri" pitchFamily="34" charset="-122"/>
-                <a:cs typeface="Calibri" pitchFamily="34" charset="-120"/>
-              </a:rPr>
-              <a:t>Piezo or 1 W speaker + PAM8302, $6 — IAudioOutput</a:t>
-            </a:r>
-            <a:endParaRPr lang="en-US" sz="1250" dirty="0"/>
-          </a:p>
-        </p:txBody>
-      </p:sp>
-      <p:sp>
-        <p:nvSpPr>
-          <p:cNvPr id="15" name="Text 12"/>
-          <p:cNvSpPr/>
-          <p:nvPr/>
-        </p:nvSpPr>
-        <p:spPr>
-          <a:xfrm>
-            <a:off x="640080" y="4617720"/>
-            <a:ext cx="1737360" cy="566928"/>
-          </a:xfrm>
-          <a:prstGeom prst="rect">
-            <a:avLst/>
-          </a:prstGeom>
-          <a:noFill/>
-          <a:ln/>
-        </p:spPr>
-        <p:txBody>
-          <a:bodyPr wrap="square" lIns="0" tIns="0" rIns="0" bIns="0" rtlCol="0" anchor="t"/>
-          <a:lstStyle/>
-          <a:p>
-            <a:pPr indent="0" marL="0">
-              <a:buNone/>
-            </a:pPr>
-            <a:r>
-              <a:rPr lang="en-US" sz="1250" b="1" dirty="0">
-                <a:solidFill>
-                  <a:srgbClr val="0E5E63"/>
-                </a:solidFill>
-                <a:latin typeface="Calibri" pitchFamily="34" charset="0"/>
-                <a:ea typeface="Calibri" pitchFamily="34" charset="-122"/>
-                <a:cs typeface="Calibri" pitchFamily="34" charset="-120"/>
-              </a:rPr>
-              <a:t>Haptics</a:t>
-            </a:r>
-            <a:endParaRPr lang="en-US" sz="1250" dirty="0"/>
-          </a:p>
-        </p:txBody>
-      </p:sp>
-      <p:sp>
-        <p:nvSpPr>
-          <p:cNvPr id="16" name="Text 13"/>
-          <p:cNvSpPr/>
-          <p:nvPr/>
-        </p:nvSpPr>
-        <p:spPr>
-          <a:xfrm>
-            <a:off x="2468880" y="4617720"/>
-            <a:ext cx="5760720" cy="566928"/>
-          </a:xfrm>
-          <a:prstGeom prst="rect">
-            <a:avLst/>
-          </a:prstGeom>
-          <a:noFill/>
-          <a:ln/>
-        </p:spPr>
-        <p:txBody>
-          <a:bodyPr wrap="square" lIns="0" tIns="0" rIns="0" bIns="0" rtlCol="0" anchor="t"/>
-          <a:lstStyle/>
-          <a:p>
-            <a:pPr indent="0" marL="0">
-              <a:buNone/>
-            </a:pPr>
-            <a:r>
-              <a:rPr lang="en-US" sz="1250" dirty="0">
-                <a:solidFill>
-                  <a:srgbClr val="12262A"/>
-                </a:solidFill>
-                <a:latin typeface="Calibri" pitchFamily="34" charset="0"/>
-                <a:ea typeface="Calibri" pitchFamily="34" charset="-122"/>
-                <a:cs typeface="Calibri" pitchFamily="34" charset="-120"/>
-              </a:rPr>
-              <a:t>Vibration disc, $2 — stretch goal</a:t>
-            </a:r>
-            <a:endParaRPr lang="en-US" sz="1250" dirty="0"/>
-          </a:p>
-        </p:txBody>
-      </p:sp>
-      <p:sp>
-        <p:nvSpPr>
-          <p:cNvPr id="17" name="Text 14"/>
-          <p:cNvSpPr/>
-          <p:nvPr/>
-        </p:nvSpPr>
-        <p:spPr>
-          <a:xfrm>
-            <a:off x="640080" y="5184648"/>
-            <a:ext cx="1737360" cy="566928"/>
-          </a:xfrm>
-          <a:prstGeom prst="rect">
-            <a:avLst/>
-          </a:prstGeom>
-          <a:noFill/>
-          <a:ln/>
-        </p:spPr>
-        <p:txBody>
-          <a:bodyPr wrap="square" lIns="0" tIns="0" rIns="0" bIns="0" rtlCol="0" anchor="t"/>
-          <a:lstStyle/>
-          <a:p>
-            <a:pPr indent="0" marL="0">
-              <a:buNone/>
-            </a:pPr>
-            <a:r>
-              <a:rPr lang="en-US" sz="1250" b="1" dirty="0">
-                <a:solidFill>
-                  <a:srgbClr val="0E5E63"/>
-                </a:solidFill>
-                <a:latin typeface="Calibri" pitchFamily="34" charset="0"/>
-                <a:ea typeface="Calibri" pitchFamily="34" charset="-122"/>
-                <a:cs typeface="Calibri" pitchFamily="34" charset="-120"/>
-              </a:rPr>
-              <a:t>Radar</a:t>
-            </a:r>
-            <a:endParaRPr lang="en-US" sz="1250" dirty="0"/>
-          </a:p>
-        </p:txBody>
-      </p:sp>
-      <p:sp>
-        <p:nvSpPr>
-          <p:cNvPr id="18" name="Text 15"/>
-          <p:cNvSpPr/>
-          <p:nvPr/>
-        </p:nvSpPr>
-        <p:spPr>
-          <a:xfrm>
-            <a:off x="2468880" y="5184648"/>
-            <a:ext cx="5760720" cy="566928"/>
-          </a:xfrm>
-          <a:prstGeom prst="rect">
-            <a:avLst/>
-          </a:prstGeom>
-          <a:noFill/>
-          <a:ln/>
-        </p:spPr>
-        <p:txBody>
-          <a:bodyPr wrap="square" lIns="0" tIns="0" rIns="0" bIns="0" rtlCol="0" anchor="t"/>
-          <a:lstStyle/>
-          <a:p>
-            <a:pPr indent="0" marL="0">
-              <a:buNone/>
-            </a:pPr>
-            <a:r>
-              <a:rPr lang="en-US" sz="1250" dirty="0">
-                <a:solidFill>
-                  <a:srgbClr val="12262A"/>
-                </a:solidFill>
-                <a:latin typeface="Calibri" pitchFamily="34" charset="0"/>
-                <a:ea typeface="Calibri" pitchFamily="34" charset="-122"/>
-                <a:cs typeface="Calibri" pitchFamily="34" charset="-120"/>
-              </a:rPr>
-              <a:t>Grove BGT24LTR11 Doppler, $30 — DEFERRED to V2 (machine-health app); envelope reserved, not in Rev A</a:t>
-            </a:r>
-            <a:endParaRPr lang="en-US" sz="1250" dirty="0"/>
+              <a:t>5a unless the UI wants smooth scrolling (5b + haptics) or wheel-nav consolidation (5c, which also deletes item 6).</a:t>
+            </a:r>
+            <a:endParaRPr lang="en-US" sz="1150" dirty="0"/>
           </a:p>
         </p:txBody>
       </p:sp>
@@ -4722,7 +5209,7 @@
                 <a:ea typeface="Cambria" pitchFamily="34" charset="-122"/>
                 <a:cs typeface="Cambria" pitchFamily="34" charset="-120"/>
               </a:rPr>
-              <a:t>Power</a:t>
+              <a:t>Input, Aux Sensing &amp; Feedback</a:t>
             </a:r>
             <a:endParaRPr lang="en-US" sz="3200" dirty="0"/>
           </a:p>
@@ -4761,7 +5248,7 @@
                 <a:ea typeface="Calibri" pitchFamily="34" charset="-122"/>
                 <a:cs typeface="Calibri" pitchFamily="34" charset="-120"/>
               </a:rPr>
-              <a:t>Exact cell waits on the display decision — the panel dominates the budget</a:t>
+              <a:t>Settled commodity parts — no open decisions here</a:t>
             </a:r>
             <a:endParaRPr lang="en-US" sz="1450" dirty="0"/>
           </a:p>
@@ -4769,7 +5256,7 @@
       </p:sp>
       <p:pic>
         <p:nvPicPr>
-          <p:cNvPr id="4" name="Image 0" descr="img2/power.png">    </p:cNvPr>
+          <p:cNvPr id="4" name="Image 0" descr="img2/input.png">    </p:cNvPr>
           <p:cNvPicPr>
             <a:picLocks noChangeAspect="1"/>
           </p:cNvPicPr>
@@ -4783,8 +5270,8 @@
         </p:blipFill>
         <p:spPr>
           <a:xfrm>
-            <a:off x="7452360" y="1920240"/>
-            <a:ext cx="4114800" cy="2377440"/>
+            <a:off x="8412480" y="1737360"/>
+            <a:ext cx="2926080" cy="2423160"/>
           </a:xfrm>
           <a:prstGeom prst="rect">
             <a:avLst/>
@@ -4800,7 +5287,7 @@
         <p:spPr>
           <a:xfrm>
             <a:off x="640080" y="1783080"/>
-            <a:ext cx="1737360" cy="777240"/>
+            <a:ext cx="1737360" cy="566928"/>
           </a:xfrm>
           <a:prstGeom prst="rect">
             <a:avLst/>
@@ -4824,7 +5311,7 @@
                 <a:ea typeface="Calibri" pitchFamily="34" charset="-122"/>
                 <a:cs typeface="Calibri" pitchFamily="34" charset="-120"/>
               </a:rPr>
-              <a:t>Battery ✦</a:t>
+              <a:t>Encoder</a:t>
             </a:r>
             <a:endParaRPr lang="en-US" sz="1250" dirty="0"/>
           </a:p>
@@ -4839,7 +5326,7 @@
         <p:spPr>
           <a:xfrm>
             <a:off x="2468880" y="1783080"/>
-            <a:ext cx="4754880" cy="777240"/>
+            <a:ext cx="5760720" cy="566928"/>
           </a:xfrm>
           <a:prstGeom prst="rect">
             <a:avLst/>
@@ -4863,7 +5350,7 @@
                 <a:ea typeface="Calibri" pitchFamily="34" charset="-122"/>
                 <a:cs typeface="Calibri" pitchFamily="34" charset="-120"/>
               </a:rPr>
-              <a:t>Flat Li-ion/LiPo 3.7 V ~2500 mAh, protected, $15 — 100×60×8 mm flat pack per packaging direction</a:t>
+              <a:t>EC11-style rotary w/ push, $3 — primary nav, at left thumb per ID doc</a:t>
             </a:r>
             <a:endParaRPr lang="en-US" sz="1250" dirty="0"/>
           </a:p>
@@ -4877,8 +5364,8 @@
         </p:nvSpPr>
         <p:spPr>
           <a:xfrm>
-            <a:off x="640080" y="2560320"/>
-            <a:ext cx="1737360" cy="777240"/>
+            <a:off x="640080" y="2350008"/>
+            <a:ext cx="1737360" cy="566928"/>
           </a:xfrm>
           <a:prstGeom prst="rect">
             <a:avLst/>
@@ -4902,7 +5389,7 @@
                 <a:ea typeface="Calibri" pitchFamily="34" charset="-122"/>
                 <a:cs typeface="Calibri" pitchFamily="34" charset="-120"/>
               </a:rPr>
-              <a:t>Charge/boost</a:t>
+              <a:t>Buttons</a:t>
             </a:r>
             <a:endParaRPr lang="en-US" sz="1250" dirty="0"/>
           </a:p>
@@ -4916,8 +5403,8 @@
         </p:nvSpPr>
         <p:spPr>
           <a:xfrm>
-            <a:off x="2468880" y="2560320"/>
-            <a:ext cx="4754880" cy="777240"/>
+            <a:off x="2468880" y="2350008"/>
+            <a:ext cx="5760720" cy="566928"/>
           </a:xfrm>
           <a:prstGeom prst="rect">
             <a:avLst/>
@@ -4941,7 +5428,7 @@
                 <a:ea typeface="Calibri" pitchFamily="34" charset="-122"/>
                 <a:cs typeface="Calibri" pitchFamily="34" charset="-120"/>
               </a:rPr>
-              <a:t>USB-C board, 5 V / 3 A, $20 — must hold a stable 5 V under Linux load; port exits the grip base</a:t>
+              <a:t>4× 6 mm tactile, $2 — trigger + function keys</a:t>
             </a:r>
             <a:endParaRPr lang="en-US" sz="1250" dirty="0"/>
           </a:p>
@@ -4955,8 +5442,8 @@
         </p:nvSpPr>
         <p:spPr>
           <a:xfrm>
-            <a:off x="640080" y="3337560"/>
-            <a:ext cx="1737360" cy="777240"/>
+            <a:off x="640080" y="2916936"/>
+            <a:ext cx="1737360" cy="566928"/>
           </a:xfrm>
           <a:prstGeom prst="rect">
             <a:avLst/>
@@ -4980,7 +5467,7 @@
                 <a:ea typeface="Calibri" pitchFamily="34" charset="-122"/>
                 <a:cs typeface="Calibri" pitchFamily="34" charset="-120"/>
               </a:rPr>
-              <a:t>Switch</a:t>
+              <a:t>Color</a:t>
             </a:r>
             <a:endParaRPr lang="en-US" sz="1250" dirty="0"/>
           </a:p>
@@ -4994,8 +5481,8 @@
         </p:nvSpPr>
         <p:spPr>
           <a:xfrm>
-            <a:off x="2468880" y="3337560"/>
-            <a:ext cx="4754880" cy="777240"/>
+            <a:off x="2468880" y="2916936"/>
+            <a:ext cx="5760720" cy="566928"/>
           </a:xfrm>
           <a:prstGeom prst="rect">
             <a:avLst/>
@@ -5019,7 +5506,7 @@
                 <a:ea typeface="Calibri" pitchFamily="34" charset="-122"/>
                 <a:cs typeface="Calibri" pitchFamily="34" charset="-120"/>
               </a:rPr>
-              <a:t>SPDT slide, $1</a:t>
+              <a:t>TCS34725, $8 — multi-measure lineage feature</a:t>
             </a:r>
             <a:endParaRPr lang="en-US" sz="1250" dirty="0"/>
           </a:p>
@@ -5033,8 +5520,8 @@
         </p:nvSpPr>
         <p:spPr>
           <a:xfrm>
-            <a:off x="640080" y="4114800"/>
-            <a:ext cx="1737360" cy="777240"/>
+            <a:off x="640080" y="3483864"/>
+            <a:ext cx="1737360" cy="566928"/>
           </a:xfrm>
           <a:prstGeom prst="rect">
             <a:avLst/>
@@ -5058,7 +5545,7 @@
                 <a:ea typeface="Calibri" pitchFamily="34" charset="-122"/>
                 <a:cs typeface="Calibri" pitchFamily="34" charset="-120"/>
               </a:rPr>
-              <a:t>Open item</a:t>
+              <a:t>Illumination</a:t>
             </a:r>
             <a:endParaRPr lang="en-US" sz="1250" dirty="0"/>
           </a:p>
@@ -5072,8 +5559,8 @@
         </p:nvSpPr>
         <p:spPr>
           <a:xfrm>
-            <a:off x="2468880" y="4114800"/>
-            <a:ext cx="4754880" cy="777240"/>
+            <a:off x="2468880" y="3483864"/>
+            <a:ext cx="5760720" cy="566928"/>
           </a:xfrm>
           <a:prstGeom prst="rect">
             <a:avLst/>
@@ -5097,7 +5584,241 @@
                 <a:ea typeface="Calibri" pitchFamily="34" charset="-122"/>
                 <a:cs typeface="Calibri" pitchFamily="34" charset="-120"/>
               </a:rPr>
-              <a:t>Cell capacity is provisional until the DSI panel's draw is measured — don't order the battery first</a:t>
+              <a:t>2× high-CRI white LED + driver, $2 — controlled shadow casting</a:t>
+            </a:r>
+            <a:endParaRPr lang="en-US" sz="1250" dirty="0"/>
+          </a:p>
+        </p:txBody>
+      </p:sp>
+      <p:sp>
+        <p:nvSpPr>
+          <p:cNvPr id="13" name="Text 10"/>
+          <p:cNvSpPr/>
+          <p:nvPr/>
+        </p:nvSpPr>
+        <p:spPr>
+          <a:xfrm>
+            <a:off x="640080" y="4050792"/>
+            <a:ext cx="1737360" cy="566928"/>
+          </a:xfrm>
+          <a:prstGeom prst="rect">
+            <a:avLst/>
+          </a:prstGeom>
+          <a:noFill/>
+          <a:ln/>
+        </p:spPr>
+        <p:txBody>
+          <a:bodyPr wrap="square" lIns="0" tIns="0" rIns="0" bIns="0" rtlCol="0" anchor="t"/>
+          <a:lstStyle/>
+          <a:p>
+            <a:pPr indent="0" marL="0">
+              <a:buNone/>
+            </a:pPr>
+            <a:r>
+              <a:rPr lang="en-US" sz="1250" b="1" dirty="0">
+                <a:solidFill>
+                  <a:srgbClr val="0E5E63"/>
+                </a:solidFill>
+                <a:latin typeface="Calibri" pitchFamily="34" charset="0"/>
+                <a:ea typeface="Calibri" pitchFamily="34" charset="-122"/>
+                <a:cs typeface="Calibri" pitchFamily="34" charset="-120"/>
+              </a:rPr>
+              <a:t>Audio</a:t>
+            </a:r>
+            <a:endParaRPr lang="en-US" sz="1250" dirty="0"/>
+          </a:p>
+        </p:txBody>
+      </p:sp>
+      <p:sp>
+        <p:nvSpPr>
+          <p:cNvPr id="14" name="Text 11"/>
+          <p:cNvSpPr/>
+          <p:nvPr/>
+        </p:nvSpPr>
+        <p:spPr>
+          <a:xfrm>
+            <a:off x="2468880" y="4050792"/>
+            <a:ext cx="5760720" cy="566928"/>
+          </a:xfrm>
+          <a:prstGeom prst="rect">
+            <a:avLst/>
+          </a:prstGeom>
+          <a:noFill/>
+          <a:ln/>
+        </p:spPr>
+        <p:txBody>
+          <a:bodyPr wrap="square" lIns="0" tIns="0" rIns="0" bIns="0" rtlCol="0" anchor="t"/>
+          <a:lstStyle/>
+          <a:p>
+            <a:pPr indent="0" marL="0">
+              <a:buNone/>
+            </a:pPr>
+            <a:r>
+              <a:rPr lang="en-US" sz="1250" dirty="0">
+                <a:solidFill>
+                  <a:srgbClr val="12262A"/>
+                </a:solidFill>
+                <a:latin typeface="Calibri" pitchFamily="34" charset="0"/>
+                <a:ea typeface="Calibri" pitchFamily="34" charset="-122"/>
+                <a:cs typeface="Calibri" pitchFamily="34" charset="-120"/>
+              </a:rPr>
+              <a:t>Piezo or 1 W speaker + PAM8302, $6 — IAudioOutput</a:t>
+            </a:r>
+            <a:endParaRPr lang="en-US" sz="1250" dirty="0"/>
+          </a:p>
+        </p:txBody>
+      </p:sp>
+      <p:sp>
+        <p:nvSpPr>
+          <p:cNvPr id="15" name="Text 12"/>
+          <p:cNvSpPr/>
+          <p:nvPr/>
+        </p:nvSpPr>
+        <p:spPr>
+          <a:xfrm>
+            <a:off x="640080" y="4617720"/>
+            <a:ext cx="1737360" cy="566928"/>
+          </a:xfrm>
+          <a:prstGeom prst="rect">
+            <a:avLst/>
+          </a:prstGeom>
+          <a:noFill/>
+          <a:ln/>
+        </p:spPr>
+        <p:txBody>
+          <a:bodyPr wrap="square" lIns="0" tIns="0" rIns="0" bIns="0" rtlCol="0" anchor="t"/>
+          <a:lstStyle/>
+          <a:p>
+            <a:pPr indent="0" marL="0">
+              <a:buNone/>
+            </a:pPr>
+            <a:r>
+              <a:rPr lang="en-US" sz="1250" b="1" dirty="0">
+                <a:solidFill>
+                  <a:srgbClr val="0E5E63"/>
+                </a:solidFill>
+                <a:latin typeface="Calibri" pitchFamily="34" charset="0"/>
+                <a:ea typeface="Calibri" pitchFamily="34" charset="-122"/>
+                <a:cs typeface="Calibri" pitchFamily="34" charset="-120"/>
+              </a:rPr>
+              <a:t>Haptics</a:t>
+            </a:r>
+            <a:endParaRPr lang="en-US" sz="1250" dirty="0"/>
+          </a:p>
+        </p:txBody>
+      </p:sp>
+      <p:sp>
+        <p:nvSpPr>
+          <p:cNvPr id="16" name="Text 13"/>
+          <p:cNvSpPr/>
+          <p:nvPr/>
+        </p:nvSpPr>
+        <p:spPr>
+          <a:xfrm>
+            <a:off x="2468880" y="4617720"/>
+            <a:ext cx="5760720" cy="566928"/>
+          </a:xfrm>
+          <a:prstGeom prst="rect">
+            <a:avLst/>
+          </a:prstGeom>
+          <a:noFill/>
+          <a:ln/>
+        </p:spPr>
+        <p:txBody>
+          <a:bodyPr wrap="square" lIns="0" tIns="0" rIns="0" bIns="0" rtlCol="0" anchor="t"/>
+          <a:lstStyle/>
+          <a:p>
+            <a:pPr indent="0" marL="0">
+              <a:buNone/>
+            </a:pPr>
+            <a:r>
+              <a:rPr lang="en-US" sz="1250" dirty="0">
+                <a:solidFill>
+                  <a:srgbClr val="12262A"/>
+                </a:solidFill>
+                <a:latin typeface="Calibri" pitchFamily="34" charset="0"/>
+                <a:ea typeface="Calibri" pitchFamily="34" charset="-122"/>
+                <a:cs typeface="Calibri" pitchFamily="34" charset="-120"/>
+              </a:rPr>
+              <a:t>Vibration disc, $2 — stretch goal</a:t>
+            </a:r>
+            <a:endParaRPr lang="en-US" sz="1250" dirty="0"/>
+          </a:p>
+        </p:txBody>
+      </p:sp>
+      <p:sp>
+        <p:nvSpPr>
+          <p:cNvPr id="17" name="Text 14"/>
+          <p:cNvSpPr/>
+          <p:nvPr/>
+        </p:nvSpPr>
+        <p:spPr>
+          <a:xfrm>
+            <a:off x="640080" y="5184648"/>
+            <a:ext cx="1737360" cy="566928"/>
+          </a:xfrm>
+          <a:prstGeom prst="rect">
+            <a:avLst/>
+          </a:prstGeom>
+          <a:noFill/>
+          <a:ln/>
+        </p:spPr>
+        <p:txBody>
+          <a:bodyPr wrap="square" lIns="0" tIns="0" rIns="0" bIns="0" rtlCol="0" anchor="t"/>
+          <a:lstStyle/>
+          <a:p>
+            <a:pPr indent="0" marL="0">
+              <a:buNone/>
+            </a:pPr>
+            <a:r>
+              <a:rPr lang="en-US" sz="1250" b="1" dirty="0">
+                <a:solidFill>
+                  <a:srgbClr val="0E5E63"/>
+                </a:solidFill>
+                <a:latin typeface="Calibri" pitchFamily="34" charset="0"/>
+                <a:ea typeface="Calibri" pitchFamily="34" charset="-122"/>
+                <a:cs typeface="Calibri" pitchFamily="34" charset="-120"/>
+              </a:rPr>
+              <a:t>Radar</a:t>
+            </a:r>
+            <a:endParaRPr lang="en-US" sz="1250" dirty="0"/>
+          </a:p>
+        </p:txBody>
+      </p:sp>
+      <p:sp>
+        <p:nvSpPr>
+          <p:cNvPr id="18" name="Text 15"/>
+          <p:cNvSpPr/>
+          <p:nvPr/>
+        </p:nvSpPr>
+        <p:spPr>
+          <a:xfrm>
+            <a:off x="2468880" y="5184648"/>
+            <a:ext cx="5760720" cy="566928"/>
+          </a:xfrm>
+          <a:prstGeom prst="rect">
+            <a:avLst/>
+          </a:prstGeom>
+          <a:noFill/>
+          <a:ln/>
+        </p:spPr>
+        <p:txBody>
+          <a:bodyPr wrap="square" lIns="0" tIns="0" rIns="0" bIns="0" rtlCol="0" anchor="t"/>
+          <a:lstStyle/>
+          <a:p>
+            <a:pPr indent="0" marL="0">
+              <a:buNone/>
+            </a:pPr>
+            <a:r>
+              <a:rPr lang="en-US" sz="1250" dirty="0">
+                <a:solidFill>
+                  <a:srgbClr val="12262A"/>
+                </a:solidFill>
+                <a:latin typeface="Calibri" pitchFamily="34" charset="0"/>
+                <a:ea typeface="Calibri" pitchFamily="34" charset="-122"/>
+                <a:cs typeface="Calibri" pitchFamily="34" charset="-120"/>
+              </a:rPr>
+              <a:t>Grove BGT24LTR11 Doppler, $30 — DEFERRED to V2 (machine-health app); envelope reserved, not in Rev A</a:t>
             </a:r>
             <a:endParaRPr lang="en-US" sz="1250" dirty="0"/>
           </a:p>
@@ -5168,7 +5889,7 @@
                 <a:ea typeface="Cambria" pitchFamily="34" charset="-122"/>
                 <a:cs typeface="Cambria" pitchFamily="34" charset="-120"/>
               </a:rPr>
-              <a:t>Enclosure &amp; Interconnect — PCBWay Scope</a:t>
+              <a:t>Power</a:t>
             </a:r>
             <a:endParaRPr lang="en-US" sz="3200" dirty="0"/>
           </a:p>
@@ -5207,7 +5928,7 @@
                 <a:ea typeface="Calibri" pitchFamily="34" charset="-122"/>
                 <a:cs typeface="Calibri" pitchFamily="34" charset="-120"/>
               </a:rPr>
-              <a:t>$300 PCBWay credit if selected · carrier PCB freeze gate Nov 10</a:t>
+              <a:t>Exact cell waits on the display decision — the panel dominates the budget</a:t>
             </a:r>
             <a:endParaRPr lang="en-US" sz="1450" dirty="0"/>
           </a:p>
@@ -5215,7 +5936,7 @@
       </p:sp>
       <p:pic>
         <p:nvPicPr>
-          <p:cNvPr id="4" name="Image 0" descr="img2/enclosure.png">    </p:cNvPr>
+          <p:cNvPr id="4" name="Image 0" descr="img2/power.png">    </p:cNvPr>
           <p:cNvPicPr>
             <a:picLocks noChangeAspect="1"/>
           </p:cNvPicPr>
@@ -5229,8 +5950,8 @@
         </p:blipFill>
         <p:spPr>
           <a:xfrm>
-            <a:off x="7589520" y="1737360"/>
-            <a:ext cx="3977640" cy="2926080"/>
+            <a:off x="7452360" y="1920240"/>
+            <a:ext cx="4114800" cy="2377440"/>
           </a:xfrm>
           <a:prstGeom prst="rect">
             <a:avLst/>
@@ -5246,7 +5967,7 @@
         <p:spPr>
           <a:xfrm>
             <a:off x="640080" y="1783080"/>
-            <a:ext cx="1737360" cy="914400"/>
+            <a:ext cx="1737360" cy="777240"/>
           </a:xfrm>
           <a:prstGeom prst="rect">
             <a:avLst/>
@@ -5270,7 +5991,7 @@
                 <a:ea typeface="Calibri" pitchFamily="34" charset="-122"/>
                 <a:cs typeface="Calibri" pitchFamily="34" charset="-120"/>
               </a:rPr>
-              <a:t>Carrier PCB</a:t>
+              <a:t>Battery ✦</a:t>
             </a:r>
             <a:endParaRPr lang="en-US" sz="1250" dirty="0"/>
           </a:p>
@@ -5285,7 +6006,7 @@
         <p:spPr>
           <a:xfrm>
             <a:off x="2468880" y="1783080"/>
-            <a:ext cx="4846320" cy="914400"/>
+            <a:ext cx="4754880" cy="777240"/>
           </a:xfrm>
           <a:prstGeom prst="rect">
             <a:avLst/>
@@ -5309,7 +6030,7 @@
                 <a:ea typeface="Calibri" pitchFamily="34" charset="-122"/>
                 <a:cs typeface="Calibri" pitchFamily="34" charset="-120"/>
               </a:rPr>
-              <a:t>I²C hub + buttons + encoder + power distribution, ~$60 assembled — Fusion Electronics design</a:t>
+              <a:t>Flat Li-ion/LiPo 3.7 V ~2500 mAh, protected, $15 — 100×60×8 mm flat pack per packaging direction</a:t>
             </a:r>
             <a:endParaRPr lang="en-US" sz="1250" dirty="0"/>
           </a:p>
@@ -5323,8 +6044,8 @@
         </p:nvSpPr>
         <p:spPr>
           <a:xfrm>
-            <a:off x="640080" y="2697480"/>
-            <a:ext cx="1737360" cy="914400"/>
+            <a:off x="640080" y="2560320"/>
+            <a:ext cx="1737360" cy="777240"/>
           </a:xfrm>
           <a:prstGeom prst="rect">
             <a:avLst/>
@@ -5348,7 +6069,7 @@
                 <a:ea typeface="Calibri" pitchFamily="34" charset="-122"/>
                 <a:cs typeface="Calibri" pitchFamily="34" charset="-120"/>
               </a:rPr>
-              <a:t>Enclosure</a:t>
+              <a:t>Charge/boost</a:t>
             </a:r>
             <a:endParaRPr lang="en-US" sz="1250" dirty="0"/>
           </a:p>
@@ -5362,8 +6083,8 @@
         </p:nvSpPr>
         <p:spPr>
           <a:xfrm>
-            <a:off x="2468880" y="2697480"/>
-            <a:ext cx="4846320" cy="914400"/>
+            <a:off x="2468880" y="2560320"/>
+            <a:ext cx="4754880" cy="777240"/>
           </a:xfrm>
           <a:prstGeom prst="rect">
             <a:avLst/>
@@ -5387,7 +6108,7 @@
                 <a:ea typeface="Calibri" pitchFamily="34" charset="-122"/>
                 <a:cs typeface="Calibri" pitchFamily="34" charset="-120"/>
               </a:rPr>
-              <a:t>Hybrid: CNC aluminium barrel + printed polymer grip (per INDUSTRIAL_DESIGN.md), ~$120–250 — metal barrel alone likely $150–250, quote early; RF window required</a:t>
+              <a:t>USB-C board, 5 V / 3 A, $20 — must hold a stable 5 V under Linux load; port exits the grip base</a:t>
             </a:r>
             <a:endParaRPr lang="en-US" sz="1250" dirty="0"/>
           </a:p>
@@ -5401,8 +6122,8 @@
         </p:nvSpPr>
         <p:spPr>
           <a:xfrm>
-            <a:off x="640080" y="3611880"/>
-            <a:ext cx="1737360" cy="914400"/>
+            <a:off x="640080" y="3337560"/>
+            <a:ext cx="1737360" cy="777240"/>
           </a:xfrm>
           <a:prstGeom prst="rect">
             <a:avLst/>
@@ -5426,7 +6147,7 @@
                 <a:ea typeface="Calibri" pitchFamily="34" charset="-122"/>
                 <a:cs typeface="Calibri" pitchFamily="34" charset="-120"/>
               </a:rPr>
-              <a:t>Fasteners</a:t>
+              <a:t>Switch</a:t>
             </a:r>
             <a:endParaRPr lang="en-US" sz="1250" dirty="0"/>
           </a:p>
@@ -5440,8 +6161,8 @@
         </p:nvSpPr>
         <p:spPr>
           <a:xfrm>
-            <a:off x="2468880" y="3611880"/>
-            <a:ext cx="4846320" cy="914400"/>
+            <a:off x="2468880" y="3337560"/>
+            <a:ext cx="4754880" cy="777240"/>
           </a:xfrm>
           <a:prstGeom prst="rect">
             <a:avLst/>
@@ -5465,7 +6186,7 @@
                 <a:ea typeface="Calibri" pitchFamily="34" charset="-122"/>
                 <a:cs typeface="Calibri" pitchFamily="34" charset="-120"/>
               </a:rPr>
-              <a:t>JST-SH/Qwiic cables, headers, M2/M2.5 standoff kit, $15</a:t>
+              <a:t>SPDT slide, $1</a:t>
             </a:r>
             <a:endParaRPr lang="en-US" sz="1250" dirty="0"/>
           </a:p>
@@ -5479,8 +6200,8 @@
         </p:nvSpPr>
         <p:spPr>
           <a:xfrm>
-            <a:off x="640080" y="4526280"/>
-            <a:ext cx="1737360" cy="914400"/>
+            <a:off x="640080" y="4114800"/>
+            <a:ext cx="1737360" cy="777240"/>
           </a:xfrm>
           <a:prstGeom prst="rect">
             <a:avLst/>
@@ -5504,7 +6225,7 @@
                 <a:ea typeface="Calibri" pitchFamily="34" charset="-122"/>
                 <a:cs typeface="Calibri" pitchFamily="34" charset="-120"/>
               </a:rPr>
-              <a:t>Misc</a:t>
+              <a:t>Open item</a:t>
             </a:r>
             <a:endParaRPr lang="en-US" sz="1250" dirty="0"/>
           </a:p>
@@ -5518,8 +6239,8 @@
         </p:nvSpPr>
         <p:spPr>
           <a:xfrm>
-            <a:off x="2468880" y="4526280"/>
-            <a:ext cx="4846320" cy="914400"/>
+            <a:off x="2468880" y="4114800"/>
+            <a:ext cx="4754880" cy="777240"/>
           </a:xfrm>
           <a:prstGeom prst="rect">
             <a:avLst/>
@@ -5543,62 +6264,9 @@
                 <a:ea typeface="Calibri" pitchFamily="34" charset="-122"/>
                 <a:cs typeface="Calibri" pitchFamily="34" charset="-120"/>
               </a:rPr>
-              <a:t>Hookup wire, heat-shrink, $10</a:t>
+              <a:t>Cell capacity is provisional until the DSI panel's draw is measured — don't order the battery first</a:t>
             </a:r>
             <a:endParaRPr lang="en-US" sz="1250" dirty="0"/>
-          </a:p>
-        </p:txBody>
-      </p:sp>
-      <p:sp>
-        <p:nvSpPr>
-          <p:cNvPr id="13" name="Text 10"/>
-          <p:cNvSpPr/>
-          <p:nvPr/>
-        </p:nvSpPr>
-        <p:spPr>
-          <a:xfrm>
-            <a:off x="640080" y="5486400"/>
-            <a:ext cx="6675120" cy="731520"/>
-          </a:xfrm>
-          <a:prstGeom prst="rect">
-            <a:avLst/>
-          </a:prstGeom>
-          <a:noFill/>
-          <a:ln/>
-        </p:spPr>
-        <p:txBody>
-          <a:bodyPr wrap="square" lIns="0" tIns="0" rIns="0" bIns="0" rtlCol="0" anchor="t"/>
-          <a:lstStyle/>
-          <a:p>
-            <a:pPr indent="0" marL="0">
-              <a:buNone/>
-            </a:pPr>
-            <a:r>
-              <a:rPr lang="en-US" sz="1300" b="1" dirty="0">
-                <a:solidFill>
-                  <a:srgbClr val="E07A2F"/>
-                </a:solidFill>
-                <a:latin typeface="Calibri" pitchFamily="34" charset="0"/>
-                <a:ea typeface="Calibri" pitchFamily="34" charset="-122"/>
-                <a:cs typeface="Calibri" pitchFamily="34" charset="-120"/>
-              </a:rPr>
-              <a:t>Risk: </a:t>
-            </a:r>
-            <a:pPr indent="0" marL="0">
-              <a:buNone/>
-            </a:pPr>
-            <a:r>
-              <a:rPr lang="en-US" sz="1300" dirty="0">
-                <a:solidFill>
-                  <a:srgbClr val="12262A"/>
-                </a:solidFill>
-                <a:latin typeface="Calibri" pitchFamily="34" charset="0"/>
-                <a:ea typeface="Calibri" pitchFamily="34" charset="-122"/>
-                <a:cs typeface="Calibri" pitchFamily="34" charset="-120"/>
-              </a:rPr>
-              <a:t>the alu barrel is the biggest single cost swing in the build — get the PCBWay quote before locking the hybrid approach.</a:t>
-            </a:r>
-            <a:endParaRPr lang="en-US" sz="1300" dirty="0"/>
           </a:p>
         </p:txBody>
       </p:sp>
@@ -5616,7 +6284,7 @@
     <p:bg>
       <p:bgPr>
         <a:solidFill>
-          <a:srgbClr val="0B2E31"/>
+          <a:srgbClr val="FFFFFF"/>
         </a:solidFill>
       </p:bgPr>
     </p:bg>
@@ -5642,8 +6310,8 @@
         </p:nvSpPr>
         <p:spPr>
           <a:xfrm>
-            <a:off x="640080" y="457200"/>
-            <a:ext cx="10058400" cy="640080"/>
+            <a:off x="640080" y="411480"/>
+            <a:ext cx="10515600" cy="640080"/>
           </a:xfrm>
           <a:prstGeom prst="rect">
             <a:avLst/>
@@ -5659,17 +6327,17 @@
               <a:buNone/>
             </a:pPr>
             <a:r>
-              <a:rPr lang="en-US" sz="3400" b="1" dirty="0">
-                <a:solidFill>
-                  <a:srgbClr val="FFFFFF"/>
+              <a:rPr lang="en-US" sz="3200" b="1" dirty="0">
+                <a:solidFill>
+                  <a:srgbClr val="0E5E63"/>
                 </a:solidFill>
                 <a:latin typeface="Cambria" pitchFamily="34" charset="0"/>
                 <a:ea typeface="Cambria" pitchFamily="34" charset="-122"/>
                 <a:cs typeface="Cambria" pitchFamily="34" charset="-120"/>
               </a:rPr>
-              <a:t>Budget &amp; Pending Decisions</a:t>
-            </a:r>
-            <a:endParaRPr lang="en-US" sz="3400" dirty="0"/>
+              <a:t>Enclosure &amp; Interconnect — PCBWay Scope</a:t>
+            </a:r>
+            <a:endParaRPr lang="en-US" sz="3200" dirty="0"/>
           </a:p>
         </p:txBody>
       </p:sp>
@@ -5681,8 +6349,8 @@
         </p:nvSpPr>
         <p:spPr>
           <a:xfrm>
-            <a:off x="640080" y="1463040"/>
-            <a:ext cx="5120640" cy="914400"/>
+            <a:off x="640080" y="1060704"/>
+            <a:ext cx="10515600" cy="365760"/>
           </a:xfrm>
           <a:prstGeom prst="rect">
             <a:avLst/>
@@ -5698,473 +6366,406 @@
               <a:buNone/>
             </a:pPr>
             <a:r>
-              <a:rPr lang="en-US" sz="6000" b="1" dirty="0">
+              <a:rPr lang="en-US" sz="1450" i="1" dirty="0">
+                <a:solidFill>
+                  <a:srgbClr val="6E7E80"/>
+                </a:solidFill>
+                <a:latin typeface="Calibri" pitchFamily="34" charset="0"/>
+                <a:ea typeface="Calibri" pitchFamily="34" charset="-122"/>
+                <a:cs typeface="Calibri" pitchFamily="34" charset="-120"/>
+              </a:rPr>
+              <a:t>$300 PCBWay credit if selected · carrier PCB freeze gate Nov 10</a:t>
+            </a:r>
+            <a:endParaRPr lang="en-US" sz="1450" dirty="0"/>
+          </a:p>
+        </p:txBody>
+      </p:sp>
+      <p:pic>
+        <p:nvPicPr>
+          <p:cNvPr id="4" name="Image 0" descr="img2/enclosure.png">    </p:cNvPr>
+          <p:cNvPicPr>
+            <a:picLocks noChangeAspect="1"/>
+          </p:cNvPicPr>
+          <p:nvPr/>
+        </p:nvPicPr>
+        <p:blipFill>
+          <a:blip r:embed="rId1"/>
+          <a:stretch>
+            <a:fillRect/>
+          </a:stretch>
+        </p:blipFill>
+        <p:spPr>
+          <a:xfrm>
+            <a:off x="7589520" y="1737360"/>
+            <a:ext cx="3977640" cy="2926080"/>
+          </a:xfrm>
+          <a:prstGeom prst="rect">
+            <a:avLst/>
+          </a:prstGeom>
+        </p:spPr>
+      </p:pic>
+      <p:sp>
+        <p:nvSpPr>
+          <p:cNvPr id="5" name="Text 2"/>
+          <p:cNvSpPr/>
+          <p:nvPr/>
+        </p:nvSpPr>
+        <p:spPr>
+          <a:xfrm>
+            <a:off x="640080" y="1783080"/>
+            <a:ext cx="1737360" cy="914400"/>
+          </a:xfrm>
+          <a:prstGeom prst="rect">
+            <a:avLst/>
+          </a:prstGeom>
+          <a:noFill/>
+          <a:ln/>
+        </p:spPr>
+        <p:txBody>
+          <a:bodyPr wrap="square" lIns="0" tIns="0" rIns="0" bIns="0" rtlCol="0" anchor="t"/>
+          <a:lstStyle/>
+          <a:p>
+            <a:pPr indent="0" marL="0">
+              <a:buNone/>
+            </a:pPr>
+            <a:r>
+              <a:rPr lang="en-US" sz="1250" b="1" dirty="0">
+                <a:solidFill>
+                  <a:srgbClr val="0E5E63"/>
+                </a:solidFill>
+                <a:latin typeface="Calibri" pitchFamily="34" charset="0"/>
+                <a:ea typeface="Calibri" pitchFamily="34" charset="-122"/>
+                <a:cs typeface="Calibri" pitchFamily="34" charset="-120"/>
+              </a:rPr>
+              <a:t>Carrier PCB</a:t>
+            </a:r>
+            <a:endParaRPr lang="en-US" sz="1250" dirty="0"/>
+          </a:p>
+        </p:txBody>
+      </p:sp>
+      <p:sp>
+        <p:nvSpPr>
+          <p:cNvPr id="6" name="Text 3"/>
+          <p:cNvSpPr/>
+          <p:nvPr/>
+        </p:nvSpPr>
+        <p:spPr>
+          <a:xfrm>
+            <a:off x="2468880" y="1783080"/>
+            <a:ext cx="4846320" cy="914400"/>
+          </a:xfrm>
+          <a:prstGeom prst="rect">
+            <a:avLst/>
+          </a:prstGeom>
+          <a:noFill/>
+          <a:ln/>
+        </p:spPr>
+        <p:txBody>
+          <a:bodyPr wrap="square" lIns="0" tIns="0" rIns="0" bIns="0" rtlCol="0" anchor="t"/>
+          <a:lstStyle/>
+          <a:p>
+            <a:pPr indent="0" marL="0">
+              <a:buNone/>
+            </a:pPr>
+            <a:r>
+              <a:rPr lang="en-US" sz="1250" dirty="0">
+                <a:solidFill>
+                  <a:srgbClr val="12262A"/>
+                </a:solidFill>
+                <a:latin typeface="Calibri" pitchFamily="34" charset="0"/>
+                <a:ea typeface="Calibri" pitchFamily="34" charset="-122"/>
+                <a:cs typeface="Calibri" pitchFamily="34" charset="-120"/>
+              </a:rPr>
+              <a:t>I²C hub + buttons + encoder + power distribution, ~$60 assembled — Fusion Electronics design</a:t>
+            </a:r>
+            <a:endParaRPr lang="en-US" sz="1250" dirty="0"/>
+          </a:p>
+        </p:txBody>
+      </p:sp>
+      <p:sp>
+        <p:nvSpPr>
+          <p:cNvPr id="7" name="Text 4"/>
+          <p:cNvSpPr/>
+          <p:nvPr/>
+        </p:nvSpPr>
+        <p:spPr>
+          <a:xfrm>
+            <a:off x="640080" y="2697480"/>
+            <a:ext cx="1737360" cy="914400"/>
+          </a:xfrm>
+          <a:prstGeom prst="rect">
+            <a:avLst/>
+          </a:prstGeom>
+          <a:noFill/>
+          <a:ln/>
+        </p:spPr>
+        <p:txBody>
+          <a:bodyPr wrap="square" lIns="0" tIns="0" rIns="0" bIns="0" rtlCol="0" anchor="t"/>
+          <a:lstStyle/>
+          <a:p>
+            <a:pPr indent="0" marL="0">
+              <a:buNone/>
+            </a:pPr>
+            <a:r>
+              <a:rPr lang="en-US" sz="1250" b="1" dirty="0">
+                <a:solidFill>
+                  <a:srgbClr val="0E5E63"/>
+                </a:solidFill>
+                <a:latin typeface="Calibri" pitchFamily="34" charset="0"/>
+                <a:ea typeface="Calibri" pitchFamily="34" charset="-122"/>
+                <a:cs typeface="Calibri" pitchFamily="34" charset="-120"/>
+              </a:rPr>
+              <a:t>Enclosure</a:t>
+            </a:r>
+            <a:endParaRPr lang="en-US" sz="1250" dirty="0"/>
+          </a:p>
+        </p:txBody>
+      </p:sp>
+      <p:sp>
+        <p:nvSpPr>
+          <p:cNvPr id="8" name="Text 5"/>
+          <p:cNvSpPr/>
+          <p:nvPr/>
+        </p:nvSpPr>
+        <p:spPr>
+          <a:xfrm>
+            <a:off x="2468880" y="2697480"/>
+            <a:ext cx="4846320" cy="914400"/>
+          </a:xfrm>
+          <a:prstGeom prst="rect">
+            <a:avLst/>
+          </a:prstGeom>
+          <a:noFill/>
+          <a:ln/>
+        </p:spPr>
+        <p:txBody>
+          <a:bodyPr wrap="square" lIns="0" tIns="0" rIns="0" bIns="0" rtlCol="0" anchor="t"/>
+          <a:lstStyle/>
+          <a:p>
+            <a:pPr indent="0" marL="0">
+              <a:buNone/>
+            </a:pPr>
+            <a:r>
+              <a:rPr lang="en-US" sz="1250" dirty="0">
+                <a:solidFill>
+                  <a:srgbClr val="12262A"/>
+                </a:solidFill>
+                <a:latin typeface="Calibri" pitchFamily="34" charset="0"/>
+                <a:ea typeface="Calibri" pitchFamily="34" charset="-122"/>
+                <a:cs typeface="Calibri" pitchFamily="34" charset="-120"/>
+              </a:rPr>
+              <a:t>Hybrid: CNC aluminium barrel + printed polymer grip (per INDUSTRIAL_DESIGN.md), ~$120–250 — metal barrel alone likely $150–250, quote early; RF window required</a:t>
+            </a:r>
+            <a:endParaRPr lang="en-US" sz="1250" dirty="0"/>
+          </a:p>
+        </p:txBody>
+      </p:sp>
+      <p:sp>
+        <p:nvSpPr>
+          <p:cNvPr id="9" name="Text 6"/>
+          <p:cNvSpPr/>
+          <p:nvPr/>
+        </p:nvSpPr>
+        <p:spPr>
+          <a:xfrm>
+            <a:off x="640080" y="3611880"/>
+            <a:ext cx="1737360" cy="914400"/>
+          </a:xfrm>
+          <a:prstGeom prst="rect">
+            <a:avLst/>
+          </a:prstGeom>
+          <a:noFill/>
+          <a:ln/>
+        </p:spPr>
+        <p:txBody>
+          <a:bodyPr wrap="square" lIns="0" tIns="0" rIns="0" bIns="0" rtlCol="0" anchor="t"/>
+          <a:lstStyle/>
+          <a:p>
+            <a:pPr indent="0" marL="0">
+              <a:buNone/>
+            </a:pPr>
+            <a:r>
+              <a:rPr lang="en-US" sz="1250" b="1" dirty="0">
+                <a:solidFill>
+                  <a:srgbClr val="0E5E63"/>
+                </a:solidFill>
+                <a:latin typeface="Calibri" pitchFamily="34" charset="0"/>
+                <a:ea typeface="Calibri" pitchFamily="34" charset="-122"/>
+                <a:cs typeface="Calibri" pitchFamily="34" charset="-120"/>
+              </a:rPr>
+              <a:t>Fasteners</a:t>
+            </a:r>
+            <a:endParaRPr lang="en-US" sz="1250" dirty="0"/>
+          </a:p>
+        </p:txBody>
+      </p:sp>
+      <p:sp>
+        <p:nvSpPr>
+          <p:cNvPr id="10" name="Text 7"/>
+          <p:cNvSpPr/>
+          <p:nvPr/>
+        </p:nvSpPr>
+        <p:spPr>
+          <a:xfrm>
+            <a:off x="2468880" y="3611880"/>
+            <a:ext cx="4846320" cy="914400"/>
+          </a:xfrm>
+          <a:prstGeom prst="rect">
+            <a:avLst/>
+          </a:prstGeom>
+          <a:noFill/>
+          <a:ln/>
+        </p:spPr>
+        <p:txBody>
+          <a:bodyPr wrap="square" lIns="0" tIns="0" rIns="0" bIns="0" rtlCol="0" anchor="t"/>
+          <a:lstStyle/>
+          <a:p>
+            <a:pPr indent="0" marL="0">
+              <a:buNone/>
+            </a:pPr>
+            <a:r>
+              <a:rPr lang="en-US" sz="1250" dirty="0">
+                <a:solidFill>
+                  <a:srgbClr val="12262A"/>
+                </a:solidFill>
+                <a:latin typeface="Calibri" pitchFamily="34" charset="0"/>
+                <a:ea typeface="Calibri" pitchFamily="34" charset="-122"/>
+                <a:cs typeface="Calibri" pitchFamily="34" charset="-120"/>
+              </a:rPr>
+              <a:t>JST-SH/Qwiic cables, headers, M2/M2.5 standoff kit, $15</a:t>
+            </a:r>
+            <a:endParaRPr lang="en-US" sz="1250" dirty="0"/>
+          </a:p>
+        </p:txBody>
+      </p:sp>
+      <p:sp>
+        <p:nvSpPr>
+          <p:cNvPr id="11" name="Text 8"/>
+          <p:cNvSpPr/>
+          <p:nvPr/>
+        </p:nvSpPr>
+        <p:spPr>
+          <a:xfrm>
+            <a:off x="640080" y="4526280"/>
+            <a:ext cx="1737360" cy="914400"/>
+          </a:xfrm>
+          <a:prstGeom prst="rect">
+            <a:avLst/>
+          </a:prstGeom>
+          <a:noFill/>
+          <a:ln/>
+        </p:spPr>
+        <p:txBody>
+          <a:bodyPr wrap="square" lIns="0" tIns="0" rIns="0" bIns="0" rtlCol="0" anchor="t"/>
+          <a:lstStyle/>
+          <a:p>
+            <a:pPr indent="0" marL="0">
+              <a:buNone/>
+            </a:pPr>
+            <a:r>
+              <a:rPr lang="en-US" sz="1250" b="1" dirty="0">
+                <a:solidFill>
+                  <a:srgbClr val="0E5E63"/>
+                </a:solidFill>
+                <a:latin typeface="Calibri" pitchFamily="34" charset="0"/>
+                <a:ea typeface="Calibri" pitchFamily="34" charset="-122"/>
+                <a:cs typeface="Calibri" pitchFamily="34" charset="-120"/>
+              </a:rPr>
+              <a:t>Misc</a:t>
+            </a:r>
+            <a:endParaRPr lang="en-US" sz="1250" dirty="0"/>
+          </a:p>
+        </p:txBody>
+      </p:sp>
+      <p:sp>
+        <p:nvSpPr>
+          <p:cNvPr id="12" name="Text 9"/>
+          <p:cNvSpPr/>
+          <p:nvPr/>
+        </p:nvSpPr>
+        <p:spPr>
+          <a:xfrm>
+            <a:off x="2468880" y="4526280"/>
+            <a:ext cx="4846320" cy="914400"/>
+          </a:xfrm>
+          <a:prstGeom prst="rect">
+            <a:avLst/>
+          </a:prstGeom>
+          <a:noFill/>
+          <a:ln/>
+        </p:spPr>
+        <p:txBody>
+          <a:bodyPr wrap="square" lIns="0" tIns="0" rIns="0" bIns="0" rtlCol="0" anchor="t"/>
+          <a:lstStyle/>
+          <a:p>
+            <a:pPr indent="0" marL="0">
+              <a:buNone/>
+            </a:pPr>
+            <a:r>
+              <a:rPr lang="en-US" sz="1250" dirty="0">
+                <a:solidFill>
+                  <a:srgbClr val="12262A"/>
+                </a:solidFill>
+                <a:latin typeface="Calibri" pitchFamily="34" charset="0"/>
+                <a:ea typeface="Calibri" pitchFamily="34" charset="-122"/>
+                <a:cs typeface="Calibri" pitchFamily="34" charset="-120"/>
+              </a:rPr>
+              <a:t>Hookup wire, heat-shrink, $10</a:t>
+            </a:r>
+            <a:endParaRPr lang="en-US" sz="1250" dirty="0"/>
+          </a:p>
+        </p:txBody>
+      </p:sp>
+      <p:sp>
+        <p:nvSpPr>
+          <p:cNvPr id="13" name="Text 10"/>
+          <p:cNvSpPr/>
+          <p:nvPr/>
+        </p:nvSpPr>
+        <p:spPr>
+          <a:xfrm>
+            <a:off x="640080" y="5486400"/>
+            <a:ext cx="6675120" cy="731520"/>
+          </a:xfrm>
+          <a:prstGeom prst="rect">
+            <a:avLst/>
+          </a:prstGeom>
+          <a:noFill/>
+          <a:ln/>
+        </p:spPr>
+        <p:txBody>
+          <a:bodyPr wrap="square" lIns="0" tIns="0" rIns="0" bIns="0" rtlCol="0" anchor="t"/>
+          <a:lstStyle/>
+          <a:p>
+            <a:pPr indent="0" marL="0">
+              <a:buNone/>
+            </a:pPr>
+            <a:r>
+              <a:rPr lang="en-US" sz="1300" b="1" dirty="0">
                 <a:solidFill>
                   <a:srgbClr val="E07A2F"/>
                 </a:solidFill>
-                <a:latin typeface="Cambria" pitchFamily="34" charset="0"/>
-                <a:ea typeface="Cambria" pitchFamily="34" charset="-122"/>
-                <a:cs typeface="Cambria" pitchFamily="34" charset="-120"/>
-              </a:rPr>
-              <a:t>≈ $200–230</a:t>
-            </a:r>
-            <a:endParaRPr lang="en-US" sz="6000" dirty="0"/>
-          </a:p>
-        </p:txBody>
-      </p:sp>
-      <p:sp>
-        <p:nvSpPr>
-          <p:cNvPr id="4" name="Text 2"/>
-          <p:cNvSpPr/>
-          <p:nvPr/>
-        </p:nvSpPr>
-        <p:spPr>
-          <a:xfrm>
-            <a:off x="640080" y="2423160"/>
-            <a:ext cx="4937760" cy="548640"/>
-          </a:xfrm>
-          <a:prstGeom prst="rect">
-            <a:avLst/>
-          </a:prstGeom>
-          <a:noFill/>
-          <a:ln/>
-        </p:spPr>
-        <p:txBody>
-          <a:bodyPr wrap="square" lIns="0" tIns="0" rIns="0" bIns="0" rtlCol="0" anchor="ctr"/>
-          <a:lstStyle/>
-          <a:p>
-            <a:pPr indent="0" marL="0">
-              <a:buNone/>
-            </a:pPr>
-            <a:r>
-              <a:rPr lang="en-US" sz="1400" dirty="0">
-                <a:solidFill>
-                  <a:srgbClr val="9DBCBE"/>
-                </a:solidFill>
-                <a:latin typeface="Calibri" pitchFamily="34" charset="0"/>
-                <a:ea typeface="Calibri" pitchFamily="34" charset="-122"/>
-                <a:cs typeface="Calibri" pitchFamily="34" charset="-120"/>
-              </a:rPr>
-              <a:t>out of pocket with contest hardware + $300 PCBWay credit</a:t>
-            </a:r>
-            <a:endParaRPr lang="en-US" sz="1400" dirty="0"/>
-          </a:p>
-        </p:txBody>
-      </p:sp>
-      <p:sp>
-        <p:nvSpPr>
-          <p:cNvPr id="5" name="Text 3"/>
-          <p:cNvSpPr/>
-          <p:nvPr/>
-        </p:nvSpPr>
-        <p:spPr>
-          <a:xfrm>
-            <a:off x="640080" y="3200400"/>
-            <a:ext cx="5120640" cy="822960"/>
-          </a:xfrm>
-          <a:prstGeom prst="rect">
-            <a:avLst/>
-          </a:prstGeom>
-          <a:noFill/>
-          <a:ln/>
-        </p:spPr>
-        <p:txBody>
-          <a:bodyPr wrap="square" lIns="0" tIns="0" rIns="0" bIns="0" rtlCol="0" anchor="ctr"/>
-          <a:lstStyle/>
-          <a:p>
-            <a:pPr indent="0" marL="0">
-              <a:buNone/>
-            </a:pPr>
-            <a:r>
-              <a:rPr lang="en-US" sz="4000" b="1" dirty="0">
-                <a:solidFill>
-                  <a:srgbClr val="D8E4E5"/>
-                </a:solidFill>
-                <a:latin typeface="Cambria" pitchFamily="34" charset="0"/>
-                <a:ea typeface="Cambria" pitchFamily="34" charset="-122"/>
-                <a:cs typeface="Cambria" pitchFamily="34" charset="-120"/>
-              </a:rPr>
-              <a:t>≈ $450–500</a:t>
-            </a:r>
-            <a:endParaRPr lang="en-US" sz="4000" dirty="0"/>
-          </a:p>
-        </p:txBody>
-      </p:sp>
-      <p:sp>
-        <p:nvSpPr>
-          <p:cNvPr id="6" name="Text 4"/>
-          <p:cNvSpPr/>
-          <p:nvPr/>
-        </p:nvSpPr>
-        <p:spPr>
-          <a:xfrm>
-            <a:off x="640080" y="3977640"/>
-            <a:ext cx="4937760" cy="457200"/>
-          </a:xfrm>
-          <a:prstGeom prst="rect">
-            <a:avLst/>
-          </a:prstGeom>
-          <a:noFill/>
-          <a:ln/>
-        </p:spPr>
-        <p:txBody>
-          <a:bodyPr wrap="square" lIns="0" tIns="0" rIns="0" bIns="0" rtlCol="0" anchor="ctr"/>
-          <a:lstStyle/>
-          <a:p>
-            <a:pPr indent="0" marL="0">
-              <a:buNone/>
-            </a:pPr>
-            <a:r>
-              <a:rPr lang="en-US" sz="1400" dirty="0">
-                <a:solidFill>
-                  <a:srgbClr val="9DBCBE"/>
-                </a:solidFill>
-                <a:latin typeface="Calibri" pitchFamily="34" charset="0"/>
-                <a:ea typeface="Calibri" pitchFamily="34" charset="-122"/>
-                <a:cs typeface="Calibri" pitchFamily="34" charset="-120"/>
-              </a:rPr>
-              <a:t>fully self-funded worst case, + tools</a:t>
-            </a:r>
-            <a:endParaRPr lang="en-US" sz="1400" dirty="0"/>
-          </a:p>
-        </p:txBody>
-      </p:sp>
-      <p:sp>
-        <p:nvSpPr>
-          <p:cNvPr id="7" name="Shape 5"/>
-          <p:cNvSpPr/>
-          <p:nvPr/>
-        </p:nvSpPr>
-        <p:spPr>
-          <a:xfrm>
-            <a:off x="6217920" y="1463040"/>
-            <a:ext cx="5303520" cy="1371600"/>
-          </a:xfrm>
-          <a:prstGeom prst="roundRect">
-            <a:avLst>
-              <a:gd name="adj" fmla="val 5333"/>
-            </a:avLst>
-          </a:prstGeom>
-          <a:solidFill>
-            <a:srgbClr val="124145"/>
-          </a:solidFill>
-          <a:ln/>
-        </p:spPr>
-      </p:sp>
-      <p:sp>
-        <p:nvSpPr>
-          <p:cNvPr id="8" name="Text 6"/>
-          <p:cNvSpPr/>
-          <p:nvPr/>
-        </p:nvSpPr>
-        <p:spPr>
-          <a:xfrm>
-            <a:off x="6446520" y="1600200"/>
-            <a:ext cx="4846320" cy="365760"/>
-          </a:xfrm>
-          <a:prstGeom prst="rect">
-            <a:avLst/>
-          </a:prstGeom>
-          <a:noFill/>
-          <a:ln/>
-        </p:spPr>
-        <p:txBody>
-          <a:bodyPr wrap="square" lIns="0" tIns="0" rIns="0" bIns="0" rtlCol="0" anchor="ctr"/>
-          <a:lstStyle/>
-          <a:p>
-            <a:pPr indent="0" marL="0">
-              <a:buNone/>
-            </a:pPr>
-            <a:r>
-              <a:rPr lang="en-US" sz="1500" b="1" dirty="0">
-                <a:solidFill>
-                  <a:srgbClr val="E07A2F"/>
-                </a:solidFill>
-                <a:latin typeface="Calibri" pitchFamily="34" charset="0"/>
-                <a:ea typeface="Calibri" pitchFamily="34" charset="-122"/>
-                <a:cs typeface="Calibri" pitchFamily="34" charset="-120"/>
-              </a:rPr>
-              <a:t>1 · Display panel</a:t>
-            </a:r>
-            <a:endParaRPr lang="en-US" sz="1500" dirty="0"/>
-          </a:p>
-        </p:txBody>
-      </p:sp>
-      <p:sp>
-        <p:nvSpPr>
-          <p:cNvPr id="9" name="Text 7"/>
-          <p:cNvSpPr/>
-          <p:nvPr/>
-        </p:nvSpPr>
-        <p:spPr>
-          <a:xfrm>
-            <a:off x="6446520" y="1993392"/>
-            <a:ext cx="4846320" cy="777240"/>
-          </a:xfrm>
-          <a:prstGeom prst="rect">
-            <a:avLst/>
-          </a:prstGeom>
-          <a:noFill/>
-          <a:ln/>
-        </p:spPr>
-        <p:txBody>
-          <a:bodyPr wrap="square" lIns="0" tIns="0" rIns="0" bIns="0" rtlCol="0" anchor="t"/>
-          <a:lstStyle/>
-          <a:p>
-            <a:pPr indent="0" marL="0">
-              <a:buNone/>
-            </a:pPr>
-            <a:r>
-              <a:rPr lang="en-US" sz="1250" dirty="0">
-                <a:solidFill>
-                  <a:srgbClr val="D8E4E5"/>
-                </a:solidFill>
-                <a:latin typeface="Calibri" pitchFamily="34" charset="0"/>
-                <a:ea typeface="Calibri" pitchFamily="34" charset="-122"/>
-                <a:cs typeface="Calibri" pitchFamily="34" charset="-120"/>
-              </a:rPr>
-              <a:t>4a decided; exact DSI panel selection due — blocks battery, enclosure, renderer. Fallback gate Sep 30.</a:t>
-            </a:r>
-            <a:endParaRPr lang="en-US" sz="1250" dirty="0"/>
-          </a:p>
-        </p:txBody>
-      </p:sp>
-      <p:sp>
-        <p:nvSpPr>
-          <p:cNvPr id="10" name="Shape 8"/>
-          <p:cNvSpPr/>
-          <p:nvPr/>
-        </p:nvSpPr>
-        <p:spPr>
-          <a:xfrm>
-            <a:off x="6217920" y="3017520"/>
-            <a:ext cx="5303520" cy="1371600"/>
-          </a:xfrm>
-          <a:prstGeom prst="roundRect">
-            <a:avLst>
-              <a:gd name="adj" fmla="val 5333"/>
-            </a:avLst>
-          </a:prstGeom>
-          <a:solidFill>
-            <a:srgbClr val="124145"/>
-          </a:solidFill>
-          <a:ln/>
-        </p:spPr>
-      </p:sp>
-      <p:sp>
-        <p:nvSpPr>
-          <p:cNvPr id="11" name="Text 9"/>
-          <p:cNvSpPr/>
-          <p:nvPr/>
-        </p:nvSpPr>
-        <p:spPr>
-          <a:xfrm>
-            <a:off x="6446520" y="3154680"/>
-            <a:ext cx="4846320" cy="365760"/>
-          </a:xfrm>
-          <a:prstGeom prst="rect">
-            <a:avLst/>
-          </a:prstGeom>
-          <a:noFill/>
-          <a:ln/>
-        </p:spPr>
-        <p:txBody>
-          <a:bodyPr wrap="square" lIns="0" tIns="0" rIns="0" bIns="0" rtlCol="0" anchor="ctr"/>
-          <a:lstStyle/>
-          <a:p>
-            <a:pPr indent="0" marL="0">
-              <a:buNone/>
-            </a:pPr>
-            <a:r>
-              <a:rPr lang="en-US" sz="1500" b="1" dirty="0">
-                <a:solidFill>
-                  <a:srgbClr val="E07A2F"/>
-                </a:solidFill>
-                <a:latin typeface="Calibri" pitchFamily="34" charset="0"/>
-                <a:ea typeface="Calibri" pitchFamily="34" charset="-122"/>
-                <a:cs typeface="Calibri" pitchFamily="34" charset="-120"/>
-              </a:rPr>
-              <a:t>2 · Camera 7a vs 7b</a:t>
-            </a:r>
-            <a:endParaRPr lang="en-US" sz="1500" dirty="0"/>
-          </a:p>
-        </p:txBody>
-      </p:sp>
-      <p:sp>
-        <p:nvSpPr>
-          <p:cNvPr id="12" name="Text 10"/>
-          <p:cNvSpPr/>
-          <p:nvPr/>
-        </p:nvSpPr>
-        <p:spPr>
-          <a:xfrm>
-            <a:off x="6446520" y="3547872"/>
-            <a:ext cx="4846320" cy="777240"/>
-          </a:xfrm>
-          <a:prstGeom prst="rect">
-            <a:avLst/>
-          </a:prstGeom>
-          <a:noFill/>
-          <a:ln/>
-        </p:spPr>
-        <p:txBody>
-          <a:bodyPr wrap="square" lIns="0" tIns="0" rIns="0" bIns="0" rtlCol="0" anchor="t"/>
-          <a:lstStyle/>
-          <a:p>
-            <a:pPr indent="0" marL="0">
-              <a:buNone/>
-            </a:pPr>
-            <a:r>
-              <a:rPr lang="en-US" sz="1250" dirty="0">
-                <a:solidFill>
-                  <a:srgbClr val="D8E4E5"/>
-                </a:solidFill>
-                <a:latin typeface="Calibri" pitchFamily="34" charset="0"/>
-                <a:ea typeface="Calibri" pitchFamily="34" charset="-122"/>
-                <a:cs typeface="Calibri" pitchFamily="34" charset="-120"/>
-              </a:rPr>
-              <a:t>Blocked on confirming UNO Q camera input paths (UVC vs CSI).</a:t>
-            </a:r>
-            <a:endParaRPr lang="en-US" sz="1250" dirty="0"/>
-          </a:p>
-        </p:txBody>
-      </p:sp>
-      <p:sp>
-        <p:nvSpPr>
-          <p:cNvPr id="13" name="Shape 11"/>
-          <p:cNvSpPr/>
-          <p:nvPr/>
-        </p:nvSpPr>
-        <p:spPr>
-          <a:xfrm>
-            <a:off x="6217920" y="4572000"/>
-            <a:ext cx="5303520" cy="1371600"/>
-          </a:xfrm>
-          <a:prstGeom prst="roundRect">
-            <a:avLst>
-              <a:gd name="adj" fmla="val 5333"/>
-            </a:avLst>
-          </a:prstGeom>
-          <a:solidFill>
-            <a:srgbClr val="124145"/>
-          </a:solidFill>
-          <a:ln/>
-        </p:spPr>
-      </p:sp>
-      <p:sp>
-        <p:nvSpPr>
-          <p:cNvPr id="14" name="Text 12"/>
-          <p:cNvSpPr/>
-          <p:nvPr/>
-        </p:nvSpPr>
-        <p:spPr>
-          <a:xfrm>
-            <a:off x="6446520" y="4709160"/>
-            <a:ext cx="4846320" cy="365760"/>
-          </a:xfrm>
-          <a:prstGeom prst="rect">
-            <a:avLst/>
-          </a:prstGeom>
-          <a:noFill/>
-          <a:ln/>
-        </p:spPr>
-        <p:txBody>
-          <a:bodyPr wrap="square" lIns="0" tIns="0" rIns="0" bIns="0" rtlCol="0" anchor="ctr"/>
-          <a:lstStyle/>
-          <a:p>
-            <a:pPr indent="0" marL="0">
-              <a:buNone/>
-            </a:pPr>
-            <a:r>
-              <a:rPr lang="en-US" sz="1500" b="1" dirty="0">
-                <a:solidFill>
-                  <a:srgbClr val="E07A2F"/>
-                </a:solidFill>
-                <a:latin typeface="Calibri" pitchFamily="34" charset="0"/>
-                <a:ea typeface="Calibri" pitchFamily="34" charset="-122"/>
-                <a:cs typeface="Calibri" pitchFamily="34" charset="-120"/>
-              </a:rPr>
-              <a:t>3 · ToF 8a/8b · IMU 9a/9b</a:t>
-            </a:r>
-            <a:endParaRPr lang="en-US" sz="1500" dirty="0"/>
-          </a:p>
-        </p:txBody>
-      </p:sp>
-      <p:sp>
-        <p:nvSpPr>
-          <p:cNvPr id="15" name="Text 13"/>
-          <p:cNvSpPr/>
-          <p:nvPr/>
-        </p:nvSpPr>
-        <p:spPr>
-          <a:xfrm>
-            <a:off x="6446520" y="5102352"/>
-            <a:ext cx="4846320" cy="777240"/>
-          </a:xfrm>
-          <a:prstGeom prst="rect">
-            <a:avLst/>
-          </a:prstGeom>
-          <a:noFill/>
-          <a:ln/>
-        </p:spPr>
-        <p:txBody>
-          <a:bodyPr wrap="square" lIns="0" tIns="0" rIns="0" bIns="0" rtlCol="0" anchor="t"/>
-          <a:lstStyle/>
-          <a:p>
-            <a:pPr indent="0" marL="0">
-              <a:buNone/>
-            </a:pPr>
-            <a:r>
-              <a:rPr lang="en-US" sz="1250" dirty="0">
-                <a:solidFill>
-                  <a:srgbClr val="D8E4E5"/>
-                </a:solidFill>
-                <a:latin typeface="Calibri" pitchFamily="34" charset="0"/>
-                <a:ea typeface="Calibri" pitchFamily="34" charset="-122"/>
-                <a:cs typeface="Calibri" pitchFamily="34" charset="-120"/>
-              </a:rPr>
-              <a:t>Analysis pending. I²C either way — doesn't block carrier PCB schematic start.</a:t>
-            </a:r>
-            <a:endParaRPr lang="en-US" sz="1250" dirty="0"/>
-          </a:p>
-        </p:txBody>
-      </p:sp>
-      <p:sp>
-        <p:nvSpPr>
-          <p:cNvPr id="16" name="Text 14"/>
-          <p:cNvSpPr/>
-          <p:nvPr/>
-        </p:nvSpPr>
-        <p:spPr>
-          <a:xfrm>
-            <a:off x="640080" y="6126480"/>
-            <a:ext cx="10515600" cy="365760"/>
-          </a:xfrm>
-          <a:prstGeom prst="rect">
-            <a:avLst/>
-          </a:prstGeom>
-          <a:noFill/>
-          <a:ln/>
-        </p:spPr>
-        <p:txBody>
-          <a:bodyPr wrap="square" lIns="0" tIns="0" rIns="0" bIns="0" rtlCol="0" anchor="ctr"/>
-          <a:lstStyle/>
-          <a:p>
-            <a:pPr indent="0" marL="0">
-              <a:buNone/>
-            </a:pPr>
-            <a:r>
-              <a:rPr lang="en-US" sz="1250" i="1" dirty="0">
-                <a:solidFill>
-                  <a:srgbClr val="6E9598"/>
-                </a:solidFill>
-                <a:latin typeface="Calibri" pitchFamily="34" charset="0"/>
-                <a:ea typeface="Calibri" pitchFamily="34" charset="-122"/>
-                <a:cs typeface="Calibri" pitchFamily="34" charset="-120"/>
-              </a:rPr>
-              <a:t>Alternates are kept deliberately — no option is deleted without a decision note.</a:t>
-            </a:r>
-            <a:endParaRPr lang="en-US" sz="1250" dirty="0"/>
+                <a:latin typeface="Calibri" pitchFamily="34" charset="0"/>
+                <a:ea typeface="Calibri" pitchFamily="34" charset="-122"/>
+                <a:cs typeface="Calibri" pitchFamily="34" charset="-120"/>
+              </a:rPr>
+              <a:t>Risk: </a:t>
+            </a:r>
+            <a:pPr indent="0" marL="0">
+              <a:buNone/>
+            </a:pPr>
+            <a:r>
+              <a:rPr lang="en-US" sz="1300" dirty="0">
+                <a:solidFill>
+                  <a:srgbClr val="12262A"/>
+                </a:solidFill>
+                <a:latin typeface="Calibri" pitchFamily="34" charset="0"/>
+                <a:ea typeface="Calibri" pitchFamily="34" charset="-122"/>
+                <a:cs typeface="Calibri" pitchFamily="34" charset="-120"/>
+              </a:rPr>
+              <a:t>the alu barrel is the biggest single cost swing in the build — get the PCBWay quote before locking the hybrid approach.</a:t>
+            </a:r>
+            <a:endParaRPr lang="en-US" sz="1300" dirty="0"/>
           </a:p>
         </p:txBody>
       </p:sp>

</xml_diff>